<commit_message>
Capture technical feedback and incorporate it in five-slide pitch
</commit_message>
<xml_diff>
--- a/docs/MerchantLens-Five-Slide-Pitch.pptx
+++ b/docs/MerchantLens-Five-Slide-Pitch.pptx
@@ -2,17 +2,17 @@
 <file path=ppt/presentation.xml><?xml version="1.0" encoding="utf-8"?>
 <p:presentation xmlns:p="http://schemas.openxmlformats.org/presentationml/2006/main">
   <p:sldMasterIdLst>
-    <p:sldMasterId xmlns:r="http://schemas.openxmlformats.org/officeDocument/2006/relationships" id="2147483648" r:id="Rcec08ec0f7114b4a"/>
+    <p:sldMasterId xmlns:r="http://schemas.openxmlformats.org/officeDocument/2006/relationships" id="2147483648" r:id="R4e7b3b4e3bf84ddb"/>
   </p:sldMasterIdLst>
   <p:notesMasterIdLst>
-    <p:notesMasterId xmlns:r="http://schemas.openxmlformats.org/officeDocument/2006/relationships" r:id="R1d25fe3d7b1d4a1a"/>
+    <p:notesMasterId xmlns:r="http://schemas.openxmlformats.org/officeDocument/2006/relationships" r:id="R8578b7d98b00474e"/>
   </p:notesMasterIdLst>
   <p:sldIdLst>
-    <p:sldId xmlns:r="http://schemas.openxmlformats.org/officeDocument/2006/relationships" id="256" r:id="Rdccca52a0cc9492c"/>
-    <p:sldId xmlns:r="http://schemas.openxmlformats.org/officeDocument/2006/relationships" id="257" r:id="Rf968bfff749d4214"/>
-    <p:sldId xmlns:r="http://schemas.openxmlformats.org/officeDocument/2006/relationships" id="258" r:id="Re9fb3d5a378241cf"/>
-    <p:sldId xmlns:r="http://schemas.openxmlformats.org/officeDocument/2006/relationships" id="259" r:id="R25e87b8dec4c4fbe"/>
-    <p:sldId xmlns:r="http://schemas.openxmlformats.org/officeDocument/2006/relationships" id="260" r:id="R1f0e62c1ddb743cd"/>
+    <p:sldId xmlns:r="http://schemas.openxmlformats.org/officeDocument/2006/relationships" id="256" r:id="Rca3150d4c13f44a3"/>
+    <p:sldId xmlns:r="http://schemas.openxmlformats.org/officeDocument/2006/relationships" id="257" r:id="Rfb2be6be81714580"/>
+    <p:sldId xmlns:r="http://schemas.openxmlformats.org/officeDocument/2006/relationships" id="258" r:id="Rf7524abc31424f42"/>
+    <p:sldId xmlns:r="http://schemas.openxmlformats.org/officeDocument/2006/relationships" id="259" r:id="Rb57926921508482b"/>
+    <p:sldId xmlns:r="http://schemas.openxmlformats.org/officeDocument/2006/relationships" id="260" r:id="R6e6319c9005a42ad"/>
   </p:sldIdLst>
   <p:sldSz cx="12192000" cy="6858000"/>
   <p:notesSz cx="6858000" cy="9144000"/>
@@ -446,6 +446,166 @@
           <a:lstStyle xmlns:a="http://schemas.openxmlformats.org/drawingml/2006/main"/>
           <a:p xmlns:a="http://schemas.openxmlformats.org/drawingml/2006/main">
             <a:r>
+              <a:t>PRESENTATION STORY — 35–45 seconds</a:t>
+            </a:r>
+          </a:p>
+          <a:p xmlns:a="http://schemas.openxmlformats.org/drawingml/2006/main">
+            <a:r>
+              <a:t>Imagine a merchant saying, “I thought I lost 2,400 rupees.” We first built an interviewer to clarify that account. The most consequential feedback was that Paytm already has five layers before human support. That changes the design question: how can context survive those touchpoints? We now capture previous attempts, keep their source attached and prepare the next reviewer’s handoff. The exact five internal layer names are not confirmed; the prototype labels its stages illustrative.</a:t>
+            </a:r>
+          </a:p>
+          <a:p xmlns:a="http://schemas.openxmlformats.org/drawingml/2006/main">
+            <a:r>
+              <a:t/>
+            </a:r>
+          </a:p>
+          <a:p xmlns:a="http://schemas.openxmlformats.org/drawingml/2006/main">
+            <a:r>
+              <a:t>TECHNICAL FEEDBACK REGISTER — slide 1</a:t>
+            </a:r>
+          </a:p>
+          <a:p xmlns:a="http://schemas.openxmlformats.org/drawingml/2006/main">
+            <a:r>
+              <a:t>The five-layer statement is user-reported Paytm leader feedback. Other entries are user requirements/questions, observed failures or engineering responses, not judge quotations.</a:t>
+            </a:r>
+          </a:p>
+          <a:p xmlns:a="http://schemas.openxmlformats.org/drawingml/2006/main">
+            <a:r>
+              <a:t/>
+            </a:r>
+          </a:p>
+          <a:p xmlns:a="http://schemas.openxmlformats.org/drawingml/2006/main">
+            <a:r>
+              <a:t>F01 — Conduct a useful interview, beyond reading a form</a:t>
+            </a:r>
+          </a:p>
+          <a:p xmlns:a="http://schemas.openxmlformats.org/drawingml/2006/main">
+            <a:r>
+              <a:t>Source: User / event brief</a:t>
+            </a:r>
+          </a:p>
+          <a:p xmlns:a="http://schemas.openxmlformats.org/drawingml/2006/main">
+            <a:r>
+              <a:t>Incorporated: Adaptive follow-ups prioritize missing information, payment ambiguity and contradictions</a:t>
+            </a:r>
+          </a:p>
+          <a:p xmlns:a="http://schemas.openxmlformats.org/drawingml/2006/main">
+            <a:r>
+              <a:t>Status / limitation: Implemented; interview quality needs real merchant evaluation</a:t>
+            </a:r>
+          </a:p>
+          <a:p xmlns:a="http://schemas.openxmlformats.org/drawingml/2006/main">
+            <a:r>
+              <a:t/>
+            </a:r>
+          </a:p>
+          <a:p xmlns:a="http://schemas.openxmlformats.org/drawingml/2006/main">
+            <a:r>
+              <a:t>F02 — Include verifiability in the problem statement</a:t>
+            </a:r>
+          </a:p>
+          <a:p xmlns:a="http://schemas.openxmlformats.org/drawingml/2006/main">
+            <a:r>
+              <a:t>Source: User</a:t>
+            </a:r>
+          </a:p>
+          <a:p xmlns:a="http://schemas.openxmlformats.org/drawingml/2006/main">
+            <a:r>
+              <a:t>Incorporated: Observations cite exact received quotes and existing source turn IDs; source links stay visible</a:t>
+            </a:r>
+          </a:p>
+          <a:p xmlns:a="http://schemas.openxmlformats.org/drawingml/2006/main">
+            <a:r>
+              <a:t>Status / limitation: Provenance is checkable; no independent payment verification</a:t>
+            </a:r>
+          </a:p>
+          <a:p xmlns:a="http://schemas.openxmlformats.org/drawingml/2006/main">
+            <a:r>
+              <a:t/>
+            </a:r>
+          </a:p>
+          <a:p xmlns:a="http://schemas.openxmlformats.org/drawingml/2006/main">
+            <a:r>
+              <a:t>F29 — Remove external reference branding</a:t>
+            </a:r>
+          </a:p>
+          <a:p xmlns:a="http://schemas.openxmlformats.org/drawingml/2006/main">
+            <a:r>
+              <a:t>Source: User</a:t>
+            </a:r>
+          </a:p>
+          <a:p xmlns:a="http://schemas.openxmlformats.org/drawingml/2006/main">
+            <a:r>
+              <a:t>Incorporated: Removed comparison-project references from current app, README/build standards and reference review</a:t>
+            </a:r>
+          </a:p>
+          <a:p xmlns:a="http://schemas.openxmlformats.org/drawingml/2006/main">
+            <a:r>
+              <a:t>Status / limitation: Current presentation checked; no Git history rewrite was requested</a:t>
+            </a:r>
+          </a:p>
+          <a:p xmlns:a="http://schemas.openxmlformats.org/drawingml/2006/main">
+            <a:r>
+              <a:t/>
+            </a:r>
+          </a:p>
+          <a:p xmlns:a="http://schemas.openxmlformats.org/drawingml/2006/main">
+            <a:r>
+              <a:t>F30 — Five layers already exist before reaching human support</a:t>
+            </a:r>
+          </a:p>
+          <a:p xmlns:a="http://schemas.openxmlformats.org/drawingml/2006/main">
+            <a:r>
+              <a:t>Source: User-reported Paytm leader feedback</a:t>
+            </a:r>
+          </a:p>
+          <a:p xmlns:a="http://schemas.openxmlformats.org/drawingml/2006/main">
+            <a:r>
+              <a:t>Incorporated: Built Support journey to preserve prior checks, channels, outcomes and unresolved questions across touchpoints</a:t>
+            </a:r>
+          </a:p>
+          <a:p xmlns:a="http://schemas.openxmlformats.org/drawingml/2006/main">
+            <a:r>
+              <a:t>Status / limitation: Exact internal layer names and APIs were not provided or publicly verified; labels are explicitly illustrative</a:t>
+            </a:r>
+          </a:p>
+          <a:p xmlns:a="http://schemas.openxmlformats.org/drawingml/2006/main">
+            <a:r>
+              <a:t/>
+            </a:r>
+          </a:p>
+          <a:p xmlns:a="http://schemas.openxmlformats.org/drawingml/2006/main">
+            <a:r>
+              <a:t>F35 — Establish what already exists before proposing value</a:t>
+            </a:r>
+          </a:p>
+          <a:p xmlns:a="http://schemas.openxmlformats.org/drawingml/2006/main">
+            <a:r>
+              <a:t>Source: Public research</a:t>
+            </a:r>
+          </a:p>
+          <a:p xmlns:a="http://schemas.openxmlformats.org/drawingml/2006/main">
+            <a:r>
+              <a:t>Incorporated: Reviewed Paytm AI Soundbox and merchant help guidance; positioned the extension around context continuity and exception handoff</a:t>
+            </a:r>
+          </a:p>
+          <a:p xmlns:a="http://schemas.openxmlformats.org/drawingml/2006/main">
+            <a:r>
+              <a:t>Status / limitation: Published consumer grievance tiers must not be presented as the leader's five merchant-support layers</a:t>
+            </a:r>
+          </a:p>
+          <a:p xmlns:a="http://schemas.openxmlformats.org/drawingml/2006/main">
+            <a:r>
+              <a:t/>
+            </a:r>
+          </a:p>
+          <a:p xmlns:a="http://schemas.openxmlformats.org/drawingml/2006/main">
+            <a:r>
+              <a:t>DETAILED IMPLEMENTATION REFERENCE</a:t>
+            </a:r>
+          </a:p>
+          <a:p xmlns:a="http://schemas.openxmlformats.org/drawingml/2006/main">
+            <a:r>
               <a:t>PRESENTATION — 35 SECONDS</a:t>
             </a:r>
           </a:p>
@@ -482,6 +642,56 @@
           <a:p xmlns:a="http://schemas.openxmlformats.org/drawingml/2006/main">
             <a:r>
               <a:t>Public repository: https://github.com/gowtham66867/merchantlens-paytm (voice revision 7a794d2). Local implementation inspected on 18 October 2026. App: https://merchantlens-paytm-412542191970.asia-south1.run.app/ . No affiliation, production deployment within Paytm, or independently verified payment status is implied.</a:t>
+            </a:r>
+          </a:p>
+          <a:p xmlns:a="http://schemas.openxmlformats.org/drawingml/2006/main">
+            <a:r>
+              <a:t/>
+            </a:r>
+          </a:p>
+          <a:p xmlns:a="http://schemas.openxmlformats.org/drawingml/2006/main">
+            <a:r>
+              <a:t>CURRENT SUPPORT EXTENSION</a:t>
+            </a:r>
+          </a:p>
+          <a:p xmlns:a="http://schemas.openxmlformats.org/drawingml/2006/main">
+            <a:r>
+              <a:t>Support history is manually entered, bounded to 20 notes, source-linked and carried into the current interview graph. Edits and human requests reset approvals. Two unresolved entries recommend a human review; no stage completion is required to request it. Public checkpoints are blocked. No Paytm records or ticket API is connected. Internal exports include history; anonymized exports omit free-text details. See https://github.com/gowtham66867/merchantlens-paytm/blob/main/docs/TECHNICAL-FEEDBACK.md and docs/SUPPORT-JOURNEY.md.</a:t>
+            </a:r>
+          </a:p>
+          <a:p xmlns:a="http://schemas.openxmlformats.org/drawingml/2006/main">
+            <a:r>
+              <a:t/>
+            </a:r>
+          </a:p>
+          <a:p xmlns:a="http://schemas.openxmlformats.org/drawingml/2006/main">
+            <a:r>
+              <a:t>PRIMARY CONTEXT</a:t>
+            </a:r>
+          </a:p>
+          <a:p xmlns:a="http://schemas.openxmlformats.org/drawingml/2006/main">
+            <a:r>
+              <a:t>Paytm AI Soundbox: https://paytm.com/document/ir/press-release/AI-SB.pdf ; merchant channels: https://business.paytmpayments.com/contact-us . Published consumer grievance levels are not evidence of the five internal merchant-support layers. Repository implementation through c91a439, 18 October 2026.</a:t>
+            </a:r>
+          </a:p>
+          <a:p xmlns:a="http://schemas.openxmlformats.org/drawingml/2006/main">
+            <a:r>
+              <a:t/>
+            </a:r>
+          </a:p>
+          <a:p xmlns:a="http://schemas.openxmlformats.org/drawingml/2006/main">
+            <a:r>
+              <a:t>OPEN ITEMS</a:t>
+            </a:r>
+          </a:p>
+          <a:p xmlns:a="http://schemas.openxmlformats.org/drawingml/2006/main">
+            <a:r>
+              <a:t>Confirm the actual support layers and authorized APIs. Persist the spoken-response preference after refresh. Benchmark real multilingual/noisy audio and live Gemini interview quality. Complete production identity, privacy/security, retention, distributed abuse/cost controls and a baseline pilot. Existing backup video is a historical typed-synthetic walkthrough.</a:t>
+            </a:r>
+          </a:p>
+          <a:p xmlns:a="http://schemas.openxmlformats.org/drawingml/2006/main">
+            <a:r>
+              <a:t/>
             </a:r>
           </a:p>
         </p:txBody>
@@ -551,6 +761,191 @@
           <a:lstStyle xmlns:a="http://schemas.openxmlformats.org/drawingml/2006/main"/>
           <a:p xmlns:a="http://schemas.openxmlformats.org/drawingml/2006/main">
             <a:r>
+              <a:t>PRESENTATION STORY — 35–45 seconds</a:t>
+            </a:r>
+          </a:p>
+          <a:p xmlns:a="http://schemas.openxmlformats.org/drawingml/2006/main">
+            <a:r>
+              <a:t>The evidence must survive every handoff. We keep app status, bank settlement and Soundbox audio separate. A source quote establishes what the merchant reported, not that a payment was independently verified. Prior support attempts become received, source-linked history; corrections and unknowns remain visible. The merchant reviews the internal handoff or anonymized brief, and changes reset approval.</a:t>
+            </a:r>
+          </a:p>
+          <a:p xmlns:a="http://schemas.openxmlformats.org/drawingml/2006/main">
+            <a:r>
+              <a:t/>
+            </a:r>
+          </a:p>
+          <a:p xmlns:a="http://schemas.openxmlformats.org/drawingml/2006/main">
+            <a:r>
+              <a:t>TECHNICAL FEEDBACK REGISTER — slide 2</a:t>
+            </a:r>
+          </a:p>
+          <a:p xmlns:a="http://schemas.openxmlformats.org/drawingml/2006/main">
+            <a:r>
+              <a:t>The five-layer statement is user-reported Paytm leader feedback. Other entries are user requirements/questions, observed failures or engineering responses, not judge quotations.</a:t>
+            </a:r>
+          </a:p>
+          <a:p xmlns:a="http://schemas.openxmlformats.org/drawingml/2006/main">
+            <a:r>
+              <a:t/>
+            </a:r>
+          </a:p>
+          <a:p xmlns:a="http://schemas.openxmlformats.org/drawingml/2006/main">
+            <a:r>
+              <a:t>F03 — Separate payment failure from missing Soundbox audio</a:t>
+            </a:r>
+          </a:p>
+          <a:p xmlns:a="http://schemas.openxmlformats.org/drawingml/2006/main">
+            <a:r>
+              <a:t>Source: User / implementation review</a:t>
+            </a:r>
+          </a:p>
+          <a:p xmlns:a="http://schemas.openxmlformats.org/drawingml/2006/main">
+            <a:r>
+              <a:t>Incorporated: App entry, bank settlement and announcement are separate questions; amount meaning is clarified</a:t>
+            </a:r>
+          </a:p>
+          <a:p xmlns:a="http://schemas.openxmlformats.org/drawingml/2006/main">
+            <a:r>
+              <a:t>Status / limitation: ₹2,400 can be affected payment value; actual loss remains unverified</a:t>
+            </a:r>
+          </a:p>
+          <a:p xmlns:a="http://schemas.openxmlformats.org/drawingml/2006/main">
+            <a:r>
+              <a:t/>
+            </a:r>
+          </a:p>
+          <a:p xmlns:a="http://schemas.openxmlformats.org/drawingml/2006/main">
+            <a:r>
+              <a:t>F04 — Separate reports, estimates, assumptions and missing evidence</a:t>
+            </a:r>
+          </a:p>
+          <a:p xmlns:a="http://schemas.openxmlformats.org/drawingml/2006/main">
+            <a:r>
+              <a:t>Source: User / event brief</a:t>
+            </a:r>
+          </a:p>
+          <a:p xmlns:a="http://schemas.openxmlformats.org/drawingml/2006/main">
+            <a:r>
+              <a:t>Incorporated: Reported/estimated labels, explicit unknowns, critic checks and correction history</a:t>
+            </a:r>
+          </a:p>
+          <a:p xmlns:a="http://schemas.openxmlformats.org/drawingml/2006/main">
+            <a:r>
+              <a:t>Status / limitation: These labels do not establish financial truth or calibrated confidence</a:t>
+            </a:r>
+          </a:p>
+          <a:p xmlns:a="http://schemas.openxmlformats.org/drawingml/2006/main">
+            <a:r>
+              <a:t/>
+            </a:r>
+          </a:p>
+          <a:p xmlns:a="http://schemas.openxmlformats.org/drawingml/2006/main">
+            <a:r>
+              <a:t>F05 — Explain the context provided to the model</a:t>
+            </a:r>
+          </a:p>
+          <a:p xmlns:a="http://schemas.openxmlformats.org/drawingml/2006/main">
+            <a:r>
+              <a:t>Source: User</a:t>
+            </a:r>
+          </a:p>
+          <a:p xmlns:a="http://schemas.openxmlformats.org/drawingml/2006/main">
+            <a:r>
+              <a:t>Incorporated: Received turns/IDs, prior observations/quotes, language, required topics, gaps, corrections, curated context and role rules</a:t>
+            </a:r>
+          </a:p>
+          <a:p xmlns:a="http://schemas.openxmlformats.org/drawingml/2006/main">
+            <a:r>
+              <a:t>Status / limitation: No Paytm ledger, bank account, device telemetry or private historical corpus is connected</a:t>
+            </a:r>
+          </a:p>
+          <a:p xmlns:a="http://schemas.openxmlformats.org/drawingml/2006/main">
+            <a:r>
+              <a:t/>
+            </a:r>
+          </a:p>
+          <a:p xmlns:a="http://schemas.openxmlformats.org/drawingml/2006/main">
+            <a:r>
+              <a:t>F06 — Preserve merchant correction, redaction and control</a:t>
+            </a:r>
+          </a:p>
+          <a:p xmlns:a="http://schemas.openxmlformats.org/drawingml/2006/main">
+            <a:r>
+              <a:t>Source: User</a:t>
+            </a:r>
+          </a:p>
+          <a:p xmlns:a="http://schemas.openxmlformats.org/drawingml/2006/main">
+            <a:r>
+              <a:t>Incorporated: Edits create a new version and invalidate both audience approvals; each export needs the matching approval</a:t>
+            </a:r>
+          </a:p>
+          <a:p xmlns:a="http://schemas.openxmlformats.org/drawingml/2006/main">
+            <a:r>
+              <a:t>Status / limitation: Browser state is owner-editable; no cryptographic approval signature</a:t>
+            </a:r>
+          </a:p>
+          <a:p xmlns:a="http://schemas.openxmlformats.org/drawingml/2006/main">
+            <a:r>
+              <a:t/>
+            </a:r>
+          </a:p>
+          <a:p xmlns:a="http://schemas.openxmlformats.org/drawingml/2006/main">
+            <a:r>
+              <a:t>F26 — Protect private data and exports</a:t>
+            </a:r>
+          </a:p>
+          <a:p xmlns:a="http://schemas.openxmlformats.org/drawingml/2006/main">
+            <a:r>
+              <a:t>Source: User / engineering</a:t>
+            </a:r>
+          </a:p>
+          <a:p xmlns:a="http://schemas.openxmlformats.org/drawingml/2006/main">
+            <a:r>
+              <a:t>Incorporated: Consent, common-secret masking, selective redaction, separate internal/anonymized approval, browser-local public sessions and no persisted raw app audio</a:t>
+            </a:r>
+          </a:p>
+          <a:p xmlns:a="http://schemas.openxmlformats.org/drawingml/2006/main">
+            <a:r>
+              <a:t>Status / limitation: Not complete PII detection, encrypted enterprise storage or privacy certification; provider policies still apply</a:t>
+            </a:r>
+          </a:p>
+          <a:p xmlns:a="http://schemas.openxmlformats.org/drawingml/2006/main">
+            <a:r>
+              <a:t/>
+            </a:r>
+          </a:p>
+          <a:p xmlns:a="http://schemas.openxmlformats.org/drawingml/2006/main">
+            <a:r>
+              <a:t>F31 — Avoid making the merchant retell the story or repeat a failed loop</a:t>
+            </a:r>
+          </a:p>
+          <a:p xmlns:a="http://schemas.openxmlformats.org/drawingml/2006/main">
+            <a:r>
+              <a:t>Source: Engineering response to F30</a:t>
+            </a:r>
+          </a:p>
+          <a:p xmlns:a="http://schemas.openxmlformats.org/drawingml/2006/main">
+            <a:r>
+              <a:t>Incorporated: Prior attempt creates a source-linked merchant turn and `attempts` observation; chronology carries into internal handoff; two unresolved entries recommend human review</a:t>
+            </a:r>
+          </a:p>
+          <a:p xmlns:a="http://schemas.openxmlformats.org/drawingml/2006/main">
+            <a:r>
+              <a:t>Status / limitation: Entered manually; two notes do not prove two distinct executed actions; no autonomous diagnosis</a:t>
+            </a:r>
+          </a:p>
+          <a:p xmlns:a="http://schemas.openxmlformats.org/drawingml/2006/main">
+            <a:r>
+              <a:t/>
+            </a:r>
+          </a:p>
+          <a:p xmlns:a="http://schemas.openxmlformats.org/drawingml/2006/main">
+            <a:r>
+              <a:t>DETAILED IMPLEMENTATION REFERENCE</a:t>
+            </a:r>
+          </a:p>
+          <a:p xmlns:a="http://schemas.openxmlformats.org/drawingml/2006/main">
+            <a:r>
               <a:t>PRESENTATION — 35 SECONDS</a:t>
             </a:r>
           </a:p>
@@ -587,6 +982,56 @@
           <a:p xmlns:a="http://schemas.openxmlformats.org/drawingml/2006/main">
             <a:r>
               <a:t>Public repository: https://github.com/gowtham66867/merchantlens-paytm (voice revision 7a794d2). Local implementation inspected on 18 October 2026. App: https://merchantlens-paytm-412542191970.asia-south1.run.app/ . No affiliation, production deployment within Paytm, or independently verified payment status is implied.</a:t>
+            </a:r>
+          </a:p>
+          <a:p xmlns:a="http://schemas.openxmlformats.org/drawingml/2006/main">
+            <a:r>
+              <a:t/>
+            </a:r>
+          </a:p>
+          <a:p xmlns:a="http://schemas.openxmlformats.org/drawingml/2006/main">
+            <a:r>
+              <a:t>CURRENT SUPPORT EXTENSION</a:t>
+            </a:r>
+          </a:p>
+          <a:p xmlns:a="http://schemas.openxmlformats.org/drawingml/2006/main">
+            <a:r>
+              <a:t>Support history is manually entered, bounded to 20 notes, source-linked and carried into the current interview graph. Edits and human requests reset approvals. Two unresolved entries recommend a human review; no stage completion is required to request it. Public checkpoints are blocked. No Paytm records or ticket API is connected. Internal exports include history; anonymized exports omit free-text details. See https://github.com/gowtham66867/merchantlens-paytm/blob/main/docs/TECHNICAL-FEEDBACK.md and docs/SUPPORT-JOURNEY.md.</a:t>
+            </a:r>
+          </a:p>
+          <a:p xmlns:a="http://schemas.openxmlformats.org/drawingml/2006/main">
+            <a:r>
+              <a:t/>
+            </a:r>
+          </a:p>
+          <a:p xmlns:a="http://schemas.openxmlformats.org/drawingml/2006/main">
+            <a:r>
+              <a:t>PRIMARY CONTEXT</a:t>
+            </a:r>
+          </a:p>
+          <a:p xmlns:a="http://schemas.openxmlformats.org/drawingml/2006/main">
+            <a:r>
+              <a:t>Paytm AI Soundbox: https://paytm.com/document/ir/press-release/AI-SB.pdf ; merchant channels: https://business.paytmpayments.com/contact-us . Published consumer grievance levels are not evidence of the five internal merchant-support layers. Repository implementation through c91a439, 18 October 2026.</a:t>
+            </a:r>
+          </a:p>
+          <a:p xmlns:a="http://schemas.openxmlformats.org/drawingml/2006/main">
+            <a:r>
+              <a:t/>
+            </a:r>
+          </a:p>
+          <a:p xmlns:a="http://schemas.openxmlformats.org/drawingml/2006/main">
+            <a:r>
+              <a:t>OPEN ITEMS</a:t>
+            </a:r>
+          </a:p>
+          <a:p xmlns:a="http://schemas.openxmlformats.org/drawingml/2006/main">
+            <a:r>
+              <a:t>Confirm the actual support layers and authorized APIs. Persist the spoken-response preference after refresh. Benchmark real multilingual/noisy audio and live Gemini interview quality. Complete production identity, privacy/security, retention, distributed abuse/cost controls and a baseline pilot. Existing backup video is a historical typed-synthetic walkthrough.</a:t>
+            </a:r>
+          </a:p>
+          <a:p xmlns:a="http://schemas.openxmlformats.org/drawingml/2006/main">
+            <a:r>
+              <a:t/>
             </a:r>
           </a:p>
         </p:txBody>
@@ -656,6 +1101,316 @@
           <a:lstStyle xmlns:a="http://schemas.openxmlformats.org/drawingml/2006/main"/>
           <a:p xmlns:a="http://schemas.openxmlformats.org/drawingml/2006/main">
             <a:r>
+              <a:t>PRESENTATION STORY — 25 seconds, plus a 60-second live example</a:t>
+            </a:r>
+          </a:p>
+          <a:p xmlns:a="http://schemas.openxmlformats.org/drawingml/2006/main">
+            <a:r>
+              <a:t>Voice testing surfaced concrete issues. Browser speech recognition failed on a network path, so the configured route uses recorded audio and Gemini transcription. The interviewer later stayed silent because spoken responses were off in an older loaded tab. We preserved the draft, refreshed, enabled speech and observed playback. Refresh still resets that preference, which is an open usability issue. VAD and natural TTS work in the prototype; noisy real merchant speech still needs validation.</a:t>
+            </a:r>
+          </a:p>
+          <a:p xmlns:a="http://schemas.openxmlformats.org/drawingml/2006/main">
+            <a:r>
+              <a:t/>
+            </a:r>
+          </a:p>
+          <a:p xmlns:a="http://schemas.openxmlformats.org/drawingml/2006/main">
+            <a:r>
+              <a:t>TECHNICAL FEEDBACK REGISTER — slide 3</a:t>
+            </a:r>
+          </a:p>
+          <a:p xmlns:a="http://schemas.openxmlformats.org/drawingml/2006/main">
+            <a:r>
+              <a:t>The five-layer statement is user-reported Paytm leader feedback. Other entries are user requirements/questions, observed failures or engineering responses, not judge quotations.</a:t>
+            </a:r>
+          </a:p>
+          <a:p xmlns:a="http://schemas.openxmlformats.org/drawingml/2006/main">
+            <a:r>
+              <a:t/>
+            </a:r>
+          </a:p>
+          <a:p xmlns:a="http://schemas.openxmlformats.org/drawingml/2006/main">
+            <a:r>
+              <a:t>F15 — Browser speech recognition failed with a network error</a:t>
+            </a:r>
+          </a:p>
+          <a:p xmlns:a="http://schemas.openxmlformats.org/drawingml/2006/main">
+            <a:r>
+              <a:t>Source: Observed failure</a:t>
+            </a:r>
+          </a:p>
+          <a:p xmlns:a="http://schemas.openxmlformats.org/drawingml/2006/main">
+            <a:r>
+              <a:t>Incorporated: Configured path uses MediaRecorder → server-side Gemini transcription → editable text → explicit Send</a:t>
+            </a:r>
+          </a:p>
+          <a:p xmlns:a="http://schemas.openxmlformats.org/drawingml/2006/main">
+            <a:r>
+              <a:t>Status / limitation: Network/provider failures remain possible; legacy browser recognition only when Gemini is unavailable</a:t>
+            </a:r>
+          </a:p>
+          <a:p xmlns:a="http://schemas.openxmlformats.org/drawingml/2006/main">
+            <a:r>
+              <a:t/>
+            </a:r>
+          </a:p>
+          <a:p xmlns:a="http://schemas.openxmlformats.org/drawingml/2006/main">
+            <a:r>
+              <a:t>F16 — Add Hindi and Kannada alongside English</a:t>
+            </a:r>
+          </a:p>
+          <a:p xmlns:a="http://schemas.openxmlformats.org/drawingml/2006/main">
+            <a:r>
+              <a:t>Source: User</a:t>
+            </a:r>
+          </a:p>
+          <a:p xmlns:a="http://schemas.openxmlformats.org/drawingml/2006/main">
+            <a:r>
+              <a:t>Incorporated: Native Hindi/Kannada and romanized Hinglish selection; language/script guidance and at most one wrong-script retry</a:t>
+            </a:r>
+          </a:p>
+          <a:p xmlns:a="http://schemas.openxmlformats.org/drawingml/2006/main">
+            <a:r>
+              <a:t>Status / limitation: Synthetic multilingual smoke tests passed; real speech word error rate is unmeasured</a:t>
+            </a:r>
+          </a:p>
+          <a:p xmlns:a="http://schemas.openxmlformats.org/drawingml/2006/main">
+            <a:r>
+              <a:t/>
+            </a:r>
+          </a:p>
+          <a:p xmlns:a="http://schemas.openxmlformats.org/drawingml/2006/main">
+            <a:r>
+              <a:t>F17 — Use Wispr Flow</a:t>
+            </a:r>
+          </a:p>
+          <a:p xmlns:a="http://schemas.openxmlformats.org/drawingml/2006/main">
+            <a:r>
+              <a:t>Source: User</a:t>
+            </a:r>
+          </a:p>
+          <a:p xmlns:a="http://schemas.openxmlformats.org/drawingml/2006/main">
+            <a:r>
+              <a:t>Incorporated: External Wispr dictation inserts text into the answer field for review</a:t>
+            </a:r>
+          </a:p>
+          <a:p xmlns:a="http://schemas.openxmlformats.org/drawingml/2006/main">
+            <a:r>
+              <a:t>Status / limitation: No Wispr microphone, transcription or reasoning API is integrated</a:t>
+            </a:r>
+          </a:p>
+          <a:p xmlns:a="http://schemas.openxmlformats.org/drawingml/2006/main">
+            <a:r>
+              <a:t/>
+            </a:r>
+          </a:p>
+          <a:p xmlns:a="http://schemas.openxmlformats.org/drawingml/2006/main">
+            <a:r>
+              <a:t>F18 — Explore GPT-Live 1 and choose a working voice provider</a:t>
+            </a:r>
+          </a:p>
+          <a:p xmlns:a="http://schemas.openxmlformats.org/drawingml/2006/main">
+            <a:r>
+              <a:t>Source: User / actual API test</a:t>
+            </a:r>
+          </a:p>
+          <a:p xmlns:a="http://schemas.openxmlformats.org/drawingml/2006/main">
+            <a:r>
+              <a:t>Incorporated: OpenAI model lookup succeeded, but an audio transcription request returned `credit_balance_exhausted`; Gemini remained active</a:t>
+            </a:r>
+          </a:p>
+          <a:p xmlns:a="http://schemas.openxmlformats.org/drawingml/2006/main">
+            <a:r>
+              <a:t>Status / limitation: GPT-Live is not wired to the browser; availability/model listing is not a working voice-session test</a:t>
+            </a:r>
+          </a:p>
+          <a:p xmlns:a="http://schemas.openxmlformats.org/drawingml/2006/main">
+            <a:r>
+              <a:t/>
+            </a:r>
+          </a:p>
+          <a:p xmlns:a="http://schemas.openxmlformats.org/drawingml/2006/main">
+            <a:r>
+              <a:t>F19 — Improve voice and detect when speech ends</a:t>
+            </a:r>
+          </a:p>
+          <a:p xmlns:a="http://schemas.openxmlformats.org/drawingml/2006/main">
+            <a:r>
+              <a:t>Source: User</a:t>
+            </a:r>
+          </a:p>
+          <a:p xmlns:a="http://schemas.openxmlformats.org/drawingml/2006/main">
+            <a:r>
+              <a:t>Incorporated: Browser-supported noise suppression/echo cancellation/gain control; local energy VAD; pause options 1.2/2/3.5 seconds</a:t>
+            </a:r>
+          </a:p>
+          <a:p xmlns:a="http://schemas.openxmlformats.org/drawingml/2006/main">
+            <a:r>
+              <a:t>Status / limitation: Heuristic pause detector, not neural/semantic VAD; noise and thinking pauses can affect it</a:t>
+            </a:r>
+          </a:p>
+          <a:p xmlns:a="http://schemas.openxmlformats.org/drawingml/2006/main">
+            <a:r>
+              <a:t/>
+            </a:r>
+          </a:p>
+          <a:p xmlns:a="http://schemas.openxmlformats.org/drawingml/2006/main">
+            <a:r>
+              <a:t>F20 — Prevent empty or excessive recording</a:t>
+            </a:r>
+          </a:p>
+          <a:p xmlns:a="http://schemas.openxmlformats.org/drawingml/2006/main">
+            <a:r>
+              <a:t>Source: Engineering</a:t>
+            </a:r>
+          </a:p>
+          <a:p xmlns:a="http://schemas.openxmlformats.org/drawingml/2006/main">
+            <a:r>
+              <a:t>Incorporated: 200 ms sustained voice filters clicks; 10 seconds without detected speech discards locally; 45-second/4 MiB recording cap; stale-session cancellation</a:t>
+            </a:r>
+          </a:p>
+          <a:p xmlns:a="http://schemas.openxmlformats.org/drawingml/2006/main">
+            <a:r>
+              <a:t>Status / limitation: Manual Stop/auto-stop off are available; no hands-free full-duplex conversation</a:t>
+            </a:r>
+          </a:p>
+          <a:p xmlns:a="http://schemas.openxmlformats.org/drawingml/2006/main">
+            <a:r>
+              <a:t/>
+            </a:r>
+          </a:p>
+          <a:p xmlns:a="http://schemas.openxmlformats.org/drawingml/2006/main">
+            <a:r>
+              <a:t>F21 — Improve spoken questions</a:t>
+            </a:r>
+          </a:p>
+          <a:p xmlns:a="http://schemas.openxmlformats.org/drawingml/2006/main">
+            <a:r>
+              <a:t>Source: User</a:t>
+            </a:r>
+          </a:p>
+          <a:p xmlns:a="http://schemas.openxmlformats.org/drawingml/2006/main">
+            <a:r>
+              <a:t>Incorporated: Gemini `gemini-3.8-flash-lite-tts`, Kore voice, separate delivery metadata, Stop playback and device-voice fallback</a:t>
+            </a:r>
+          </a:p>
+          <a:p xmlns:a="http://schemas.openxmlformats.org/drawingml/2006/main">
+            <a:r>
+              <a:t>Status / limitation: Cloud generation adds delay; device voices depend on installation/browser</a:t>
+            </a:r>
+          </a:p>
+          <a:p xmlns:a="http://schemas.openxmlformats.org/drawingml/2006/main">
+            <a:r>
+              <a:t/>
+            </a:r>
+          </a:p>
+          <a:p xmlns:a="http://schemas.openxmlformats.org/drawingml/2006/main">
+            <a:r>
+              <a:t>F22 — Explain the codec</a:t>
+            </a:r>
+          </a:p>
+          <a:p xmlns:a="http://schemas.openxmlformats.org/drawingml/2006/main">
+            <a:r>
+              <a:t>Source: User</a:t>
+            </a:r>
+          </a:p>
+          <a:p xmlns:a="http://schemas.openxmlformats.org/drawingml/2006/main">
+            <a:r>
+              <a:t>Incorporated: Preferred microphone: Opus in WebM; browser-supported MP4/Ogg/default fallbacks. Tested TTS: 16-bit PCM, 24 kHz mono in WAV</a:t>
+            </a:r>
+          </a:p>
+          <a:p xmlns:a="http://schemas.openxmlformats.org/drawingml/2006/main">
+            <a:r>
+              <a:t>Status / limitation: Container differs from codec; MP4 codec/sample rate is not forced; PCM details were observed in the tested output</a:t>
+            </a:r>
+          </a:p>
+          <a:p xmlns:a="http://schemas.openxmlformats.org/drawingml/2006/main">
+            <a:r>
+              <a:t/>
+            </a:r>
+          </a:p>
+          <a:p xmlns:a="http://schemas.openxmlformats.org/drawingml/2006/main">
+            <a:r>
+              <a:t>F23 — Interviewer did not speak</a:t>
+            </a:r>
+          </a:p>
+          <a:p xmlns:a="http://schemas.openxmlformats.org/drawingml/2006/main">
+            <a:r>
+              <a:t>Source: Observed demo failure / user confirmed</a:t>
+            </a:r>
+          </a:p>
+          <a:p xmlns:a="http://schemas.openxmlformats.org/drawingml/2006/main">
+            <a:r>
+              <a:t>Incorporated: Found an older loaded UI and spoken responses switched off; preserved unsent text, refreshed, enabled speech and replayed the question; Chrome reached “Interviewer speaking”</a:t>
+            </a:r>
+          </a:p>
+          <a:p xmlns:a="http://schemas.openxmlformats.org/drawingml/2006/main">
+            <a:r>
+              <a:t>Status / limitation: **Open:** refresh currently resets spoken responses to off. Browser playing state does not prove room speakers are audible</a:t>
+            </a:r>
+          </a:p>
+          <a:p xmlns:a="http://schemas.openxmlformats.org/drawingml/2006/main">
+            <a:r>
+              <a:t/>
+            </a:r>
+          </a:p>
+          <a:p xmlns:a="http://schemas.openxmlformats.org/drawingml/2006/main">
+            <a:r>
+              <a:t>F25 — Deploy a link accessible to judges</a:t>
+            </a:r>
+          </a:p>
+          <a:p xmlns:a="http://schemas.openxmlformats.org/drawingml/2006/main">
+            <a:r>
+              <a:t>Source: User / observed infrastructure errors</a:t>
+            </a:r>
+          </a:p>
+          <a:p xmlns:a="http://schemas.openxmlformats.org/drawingml/2006/main">
+            <a:r>
+              <a:t>Incorporated: Cloud Run public demo, Docker/Node runtime, Secret Manager; IAP/public-invocation configuration corrected after Forbidden/access errors</a:t>
+            </a:r>
+          </a:p>
+          <a:p xmlns:a="http://schemas.openxmlformats.org/drawingml/2006/main">
+            <a:r>
+              <a:t>Status / limitation: Public checkpoints remain blocked; production authentication and distributed abuse controls remain future work</a:t>
+            </a:r>
+          </a:p>
+          <a:p xmlns:a="http://schemas.openxmlformats.org/drawingml/2006/main">
+            <a:r>
+              <a:t/>
+            </a:r>
+          </a:p>
+          <a:p xmlns:a="http://schemas.openxmlformats.org/drawingml/2006/main">
+            <a:r>
+              <a:t>F28 — Include demo evidence without overstating it</a:t>
+            </a:r>
+          </a:p>
+          <a:p xmlns:a="http://schemas.openxmlformats.org/drawingml/2006/main">
+            <a:r>
+              <a:t>Source: User</a:t>
+            </a:r>
+          </a:p>
+          <a:p xmlns:a="http://schemas.openxmlformats.org/drawingml/2006/main">
+            <a:r>
+              <a:t>Incorporated: Visible partial human English session documented; typed synthetic 3:44 backup video labeled; synthetic multilingual STT/TTS smoke tests and public WAV playback recorded</a:t>
+            </a:r>
+          </a:p>
+          <a:p xmlns:a="http://schemas.openxmlformats.org/drawingml/2006/main">
+            <a:r>
+              <a:t>Status / limitation: Backup video predates newer voice/support features; no native speaker or noisy-shop benchmark</a:t>
+            </a:r>
+          </a:p>
+          <a:p xmlns:a="http://schemas.openxmlformats.org/drawingml/2006/main">
+            <a:r>
+              <a:t/>
+            </a:r>
+          </a:p>
+          <a:p xmlns:a="http://schemas.openxmlformats.org/drawingml/2006/main">
+            <a:r>
+              <a:t>DETAILED IMPLEMENTATION REFERENCE</a:t>
+            </a:r>
+          </a:p>
+          <a:p xmlns:a="http://schemas.openxmlformats.org/drawingml/2006/main">
+            <a:r>
               <a:t>PRESENTATION — 25 SECONDS, THEN 60–75 SECONDS OF LIVE DEMO</a:t>
             </a:r>
           </a:p>
@@ -732,6 +1487,56 @@
           <a:p xmlns:a="http://schemas.openxmlformats.org/drawingml/2006/main">
             <a:r>
               <a:t>Public repository: https://github.com/gowtham66867/merchantlens-paytm (voice revision 7a794d2). Local implementation inspected on 18 October 2026. App: https://merchantlens-paytm-412542191970.asia-south1.run.app/ . No affiliation, production deployment within Paytm, or independently verified payment status is implied.</a:t>
+            </a:r>
+          </a:p>
+          <a:p xmlns:a="http://schemas.openxmlformats.org/drawingml/2006/main">
+            <a:r>
+              <a:t/>
+            </a:r>
+          </a:p>
+          <a:p xmlns:a="http://schemas.openxmlformats.org/drawingml/2006/main">
+            <a:r>
+              <a:t>CURRENT SUPPORT EXTENSION</a:t>
+            </a:r>
+          </a:p>
+          <a:p xmlns:a="http://schemas.openxmlformats.org/drawingml/2006/main">
+            <a:r>
+              <a:t>Support history is manually entered, bounded to 20 notes, source-linked and carried into the current interview graph. Edits and human requests reset approvals. Two unresolved entries recommend a human review; no stage completion is required to request it. Public checkpoints are blocked. No Paytm records or ticket API is connected. Internal exports include history; anonymized exports omit free-text details. See https://github.com/gowtham66867/merchantlens-paytm/blob/main/docs/TECHNICAL-FEEDBACK.md and docs/SUPPORT-JOURNEY.md.</a:t>
+            </a:r>
+          </a:p>
+          <a:p xmlns:a="http://schemas.openxmlformats.org/drawingml/2006/main">
+            <a:r>
+              <a:t/>
+            </a:r>
+          </a:p>
+          <a:p xmlns:a="http://schemas.openxmlformats.org/drawingml/2006/main">
+            <a:r>
+              <a:t>PRIMARY CONTEXT</a:t>
+            </a:r>
+          </a:p>
+          <a:p xmlns:a="http://schemas.openxmlformats.org/drawingml/2006/main">
+            <a:r>
+              <a:t>Paytm AI Soundbox: https://paytm.com/document/ir/press-release/AI-SB.pdf ; merchant channels: https://business.paytmpayments.com/contact-us . Published consumer grievance levels are not evidence of the five internal merchant-support layers. Repository implementation through c91a439, 18 October 2026.</a:t>
+            </a:r>
+          </a:p>
+          <a:p xmlns:a="http://schemas.openxmlformats.org/drawingml/2006/main">
+            <a:r>
+              <a:t/>
+            </a:r>
+          </a:p>
+          <a:p xmlns:a="http://schemas.openxmlformats.org/drawingml/2006/main">
+            <a:r>
+              <a:t>OPEN ITEMS</a:t>
+            </a:r>
+          </a:p>
+          <a:p xmlns:a="http://schemas.openxmlformats.org/drawingml/2006/main">
+            <a:r>
+              <a:t>Confirm the actual support layers and authorized APIs. Persist the spoken-response preference after refresh. Benchmark real multilingual/noisy audio and live Gemini interview quality. Complete production identity, privacy/security, retention, distributed abuse/cost controls and a baseline pilot. Existing backup video is a historical typed-synthetic walkthrough.</a:t>
+            </a:r>
+          </a:p>
+          <a:p xmlns:a="http://schemas.openxmlformats.org/drawingml/2006/main">
+            <a:r>
+              <a:t/>
             </a:r>
           </a:p>
         </p:txBody>
@@ -801,12 +1606,297 @@
           <a:lstStyle xmlns:a="http://schemas.openxmlformats.org/drawingml/2006/main"/>
           <a:p xmlns:a="http://schemas.openxmlformats.org/drawingml/2006/main">
             <a:r>
+              <a:t>PRESENTATION STORY — 35–45 seconds</a:t>
+            </a:r>
+          </a:p>
+          <a:p xmlns:a="http://schemas.openxmlformats.org/drawingml/2006/main">
+            <a:r>
+              <a:t>Three Gemini roles communicate through structured JSON controlled by one orchestrator. Exact-source checks, allowed tools, call budgets and export authority remain in code. Critique and read-only tools run in parallel and join before planning. We have 61 passing regression tests and seven visible guided probes. Those checks and synthetic audio smoke tests are useful engineering evidence, not a live-model interview accuracy score.</a:t>
+            </a:r>
+          </a:p>
+          <a:p xmlns:a="http://schemas.openxmlformats.org/drawingml/2006/main">
+            <a:r>
+              <a:t/>
+            </a:r>
+          </a:p>
+          <a:p xmlns:a="http://schemas.openxmlformats.org/drawingml/2006/main">
+            <a:r>
+              <a:t>TECHNICAL FEEDBACK REGISTER — slide 4</a:t>
+            </a:r>
+          </a:p>
+          <a:p xmlns:a="http://schemas.openxmlformats.org/drawingml/2006/main">
+            <a:r>
+              <a:t>The five-layer statement is user-reported Paytm leader feedback. Other entries are user requirements/questions, observed failures or engineering responses, not judge quotations.</a:t>
+            </a:r>
+          </a:p>
+          <a:p xmlns:a="http://schemas.openxmlformats.org/drawingml/2006/main">
+            <a:r>
+              <a:t/>
+            </a:r>
+          </a:p>
+          <a:p xmlns:a="http://schemas.openxmlformats.org/drawingml/2006/main">
+            <a:r>
+              <a:t>F07 — Explain communication between agents</a:t>
+            </a:r>
+          </a:p>
+          <a:p xmlns:a="http://schemas.openxmlformats.org/drawingml/2006/main">
+            <a:r>
+              <a:t>Source: User</a:t>
+            </a:r>
+          </a:p>
+          <a:p xmlns:a="http://schemas.openxmlformats.org/drawingml/2006/main">
+            <a:r>
+              <a:t>Incorporated: Central TypeScript orchestrator passes schema-constrained JSON between extractor, critic and planner</a:t>
+            </a:r>
+          </a:p>
+          <a:p xmlns:a="http://schemas.openxmlformats.org/drawingml/2006/main">
+            <a:r>
+              <a:t>Status / limitation: Separately scoped Gemini requests; no direct A2A protocol, message broker or audio between roles</a:t>
+            </a:r>
+          </a:p>
+          <a:p xmlns:a="http://schemas.openxmlformats.org/drawingml/2006/main">
+            <a:r>
+              <a:t/>
+            </a:r>
+          </a:p>
+          <a:p xmlns:a="http://schemas.openxmlformats.org/drawingml/2006/main">
+            <a:r>
+              <a:t>F08 — Use advanced agentic concepts with a sound architecture</a:t>
+            </a:r>
+          </a:p>
+          <a:p xmlns:a="http://schemas.openxmlformats.org/drawingml/2006/main">
+            <a:r>
+              <a:t>Source: User</a:t>
+            </a:r>
+          </a:p>
+          <a:p xmlns:a="http://schemas.openxmlformats.org/drawingml/2006/main">
+            <a:r>
+              <a:t>Incorporated: Stateful graph, structured extraction, critique, parallel tools, gap ranking, conditional policy gate and bounded repair</a:t>
+            </a:r>
+          </a:p>
+          <a:p xmlns:a="http://schemas.openxmlformats.org/drawingml/2006/main">
+            <a:r>
+              <a:t>Status / limitation: Same Gemini backend; not independent model consensus or an autonomous swarm</a:t>
+            </a:r>
+          </a:p>
+          <a:p xmlns:a="http://schemas.openxmlformats.org/drawingml/2006/main">
+            <a:r>
+              <a:t/>
+            </a:r>
+          </a:p>
+          <a:p xmlns:a="http://schemas.openxmlformats.org/drawingml/2006/main">
+            <a:r>
+              <a:t>F09 — Explain harness engineering</a:t>
+            </a:r>
+          </a:p>
+          <a:p xmlns:a="http://schemas.openxmlformats.org/drawingml/2006/main">
+            <a:r>
+              <a:t>Source: User</a:t>
+            </a:r>
+          </a:p>
+          <a:p xmlns:a="http://schemas.openxmlformats.org/drawingml/2006/main">
+            <a:r>
+              <a:t>Incorporated: Code controls input boundaries, exact-source checks, topic selection, safe response form, budgets, failures and approval authority</a:t>
+            </a:r>
+          </a:p>
+          <a:p xmlns:a="http://schemas.openxmlformats.org/drawingml/2006/main">
+            <a:r>
+              <a:t>Status / limitation: A harness is the control system around inference, not merely a prompt</a:t>
+            </a:r>
+          </a:p>
+          <a:p xmlns:a="http://schemas.openxmlformats.org/drawingml/2006/main">
+            <a:r>
+              <a:t/>
+            </a:r>
+          </a:p>
+          <a:p xmlns:a="http://schemas.openxmlformats.org/drawingml/2006/main">
+            <a:r>
+              <a:t>F10 — Bound execution and repairs</a:t>
+            </a:r>
+          </a:p>
+          <a:p xmlns:a="http://schemas.openxmlformats.org/drawingml/2006/main">
+            <a:r>
+              <a:t>Source: Engineering</a:t>
+            </a:r>
+          </a:p>
+          <a:p xmlns:a="http://schemas.openxmlformats.org/drawingml/2006/main">
+            <a:r>
+              <a:t>Incorporated: Per turn: at most 4 model calls, 3 read-only tool calls, one shared role repair, 55-second graph deadline; at most 14 merchant turns</a:t>
+            </a:r>
+          </a:p>
+          <a:p xmlns:a="http://schemas.openxmlformats.org/drawingml/2006/main">
+            <a:r>
+              <a:t>Status / limitation: Repair consumes the same call budget; no unbounded background loop</a:t>
+            </a:r>
+          </a:p>
+          <a:p xmlns:a="http://schemas.openxmlformats.org/drawingml/2006/main">
+            <a:r>
+              <a:t/>
+            </a:r>
+          </a:p>
+          <a:p xmlns:a="http://schemas.openxmlformats.org/drawingml/2006/main">
+            <a:r>
+              <a:t>F11 — Make tools, memory and retrieval inspectable</a:t>
+            </a:r>
+          </a:p>
+          <a:p xmlns:a="http://schemas.openxmlformats.org/drawingml/2006/main">
+            <a:r>
+              <a:t>Source: User / engineering</a:t>
+            </a:r>
+          </a:p>
+          <a:p xmlns:a="http://schemas.openxmlformats.org/drawingml/2006/main">
+            <a:r>
+              <a:t>Incorporated: Allowlisted coverage/evidence/context tools; typed interview state; actual trace of calls, tools, tokens, timings and source fingerprint</a:t>
+            </a:r>
+          </a:p>
+          <a:p xmlns:a="http://schemas.openxmlformats.org/drawingml/2006/main">
+            <a:r>
+              <a:t>Status / limitation: Curated lexical retrieval, not web/vector RAG; fingerprint is not a signature</a:t>
+            </a:r>
+          </a:p>
+          <a:p xmlns:a="http://schemas.openxmlformats.org/drawingml/2006/main">
+            <a:r>
+              <a:t/>
+            </a:r>
+          </a:p>
+          <a:p xmlns:a="http://schemas.openxmlformats.org/drawingml/2006/main">
+            <a:r>
+              <a:t>F12 — Show what changes when evidence is removed</a:t>
+            </a:r>
+          </a:p>
+          <a:p xmlns:a="http://schemas.openxmlformats.org/drawingml/2006/main">
+            <a:r>
+              <a:t>Source: User</a:t>
+            </a:r>
+          </a:p>
+          <a:p xmlns:a="http://schemas.openxmlformats.org/drawingml/2006/main">
+            <a:r>
+              <a:t>Incorporated: Source-ablation explorer identifies observations depending on a removed turn</a:t>
+            </a:r>
+          </a:p>
+          <a:p xmlns:a="http://schemas.openxmlformats.org/drawingml/2006/main">
+            <a:r>
+              <a:t>Status / limitation: Dependency test, not causal inference</a:t>
+            </a:r>
+          </a:p>
+          <a:p xmlns:a="http://schemas.openxmlformats.org/drawingml/2006/main">
+            <a:r>
+              <a:t/>
+            </a:r>
+          </a:p>
+          <a:p xmlns:a="http://schemas.openxmlformats.org/drawingml/2006/main">
+            <a:r>
+              <a:t>F13 — Explain guardrails and authority</a:t>
+            </a:r>
+          </a:p>
+          <a:p xmlns:a="http://schemas.openxmlformats.org/drawingml/2006/main">
+            <a:r>
+              <a:t>Source: User</a:t>
+            </a:r>
+          </a:p>
+          <a:p xmlns:a="http://schemas.openxmlformats.org/drawingml/2006/main">
+            <a:r>
+              <a:t>Incorporated: Untrusted transcript/tool content; exact quote/source checks; safe candidate override; secret masking; no payment/refund tools; no model-granted approval</a:t>
+            </a:r>
+          </a:p>
+          <a:p xmlns:a="http://schemas.openxmlformats.org/drawingml/2006/main">
+            <a:r>
+              <a:t>Status / limitation: Heuristics and regex checks are incomplete; production review remains necessary</a:t>
+            </a:r>
+          </a:p>
+          <a:p xmlns:a="http://schemas.openxmlformats.org/drawingml/2006/main">
+            <a:r>
+              <a:t/>
+            </a:r>
+          </a:p>
+          <a:p xmlns:a="http://schemas.openxmlformats.org/drawingml/2006/main">
+            <a:r>
+              <a:t>F14 — Define exit criteria</a:t>
+            </a:r>
+          </a:p>
+          <a:p xmlns:a="http://schemas.openxmlformats.org/drawingml/2006/main">
+            <a:r>
+              <a:t>Source: User</a:t>
+            </a:r>
+          </a:p>
+          <a:p xmlns:a="http://schemas.openxmlformats.org/drawingml/2006/main">
+            <a:r>
+              <a:t>Incorporated: Stop on merchant request, sufficient topic coverage or turn limit; preserve unknowns; provider failure retains pending answer and prior committed state</a:t>
+            </a:r>
+          </a:p>
+          <a:p xmlns:a="http://schemas.openxmlformats.org/drawingml/2006/main">
+            <a:r>
+              <a:t>Status / limitation: Coverage is not truth, resolution or interview-quality verification</a:t>
+            </a:r>
+          </a:p>
+          <a:p xmlns:a="http://schemas.openxmlformats.org/drawingml/2006/main">
+            <a:r>
+              <a:t/>
+            </a:r>
+          </a:p>
+          <a:p xmlns:a="http://schemas.openxmlformats.org/drawingml/2006/main">
+            <a:r>
+              <a:t>F24 — Prepare live evals and validation</a:t>
+            </a:r>
+          </a:p>
+          <a:p xmlns:a="http://schemas.openxmlformats.org/drawingml/2006/main">
+            <a:r>
+              <a:t>Source: User</a:t>
+            </a:r>
+          </a:p>
+          <a:p xmlns:a="http://schemas.openxmlformats.org/drawingml/2006/main">
+            <a:r>
+              <a:t>Incorporated: 61 automated tests passed after support-journey addition; 7 visible guided probes exercise amount ambiguity, signal separation, early stop, injection, damaged device, unknown bank evidence and fabricated quote rejection</a:t>
+            </a:r>
+          </a:p>
+          <a:p xmlns:a="http://schemas.openxmlformats.org/drawingml/2006/main">
+            <a:r>
+              <a:t>Status / limitation: Guided/contract checks, not a live-model accuracy benchmark; synthetic voice smoke tests are separate</a:t>
+            </a:r>
+          </a:p>
+          <a:p xmlns:a="http://schemas.openxmlformats.org/drawingml/2006/main">
+            <a:r>
+              <a:t/>
+            </a:r>
+          </a:p>
+          <a:p xmlns:a="http://schemas.openxmlformats.org/drawingml/2006/main">
+            <a:r>
+              <a:t>F27 — Preserve explicit state and handle concurrent saves</a:t>
+            </a:r>
+          </a:p>
+          <a:p xmlns:a="http://schemas.openxmlformats.org/drawingml/2006/main">
+            <a:r>
+              <a:t>Source: Engineering</a:t>
+            </a:r>
+          </a:p>
+          <a:p xmlns:a="http://schemas.openxmlformats.org/drawingml/2006/main">
+            <a:r>
+              <a:t>Incorporated: Optional private D1/Cloud Storage adapters, owner scoping, observed-version/generation checks and approval-only concurrency checks</a:t>
+            </a:r>
+          </a:p>
+          <a:p xmlns:a="http://schemas.openxmlformats.org/drawingml/2006/main">
+            <a:r>
+              <a:t>Status / limitation: Public demo has no shared cloud interview database; old downloaded copies cannot be recalled</a:t>
+            </a:r>
+          </a:p>
+          <a:p xmlns:a="http://schemas.openxmlformats.org/drawingml/2006/main">
+            <a:r>
+              <a:t/>
+            </a:r>
+          </a:p>
+          <a:p xmlns:a="http://schemas.openxmlformats.org/drawingml/2006/main">
+            <a:r>
+              <a:t>DETAILED IMPLEMENTATION REFERENCE</a:t>
+            </a:r>
+          </a:p>
+          <a:p xmlns:a="http://schemas.openxmlformats.org/drawingml/2006/main">
+            <a:r>
               <a:t>PRESENTATION — 45 SECONDS</a:t>
             </a:r>
           </a:p>
           <a:p xmlns:a="http://schemas.openxmlformats.org/drawingml/2006/main">
             <a:r>
-              <a:t>The model does not control the whole workflow. One custom harness coordinates three Gemini roles: an extractor, a critic and a planner. Exact-source checks and the final policy gate run in code. Critique and read-only context tools can run in parallel. If the planner ignores a critical ambiguity, the gate can override it. The limits are explicit: four calls, three tools and one repair per turn. The merchant’s words never become permission to approve an export. We have 56 passing regression tests and seven visible guided probes; those are not a claim of live-model accuracy.</a:t>
+              <a:t>The model does not control the whole workflow. One custom harness coordinates three Gemini roles: an extractor, a critic and a planner. Exact-source checks and the final policy gate run in code. Critique and read-only context tools can run in parallel. If the planner ignores a critical ambiguity, the gate can override it. The limits are explicit: four calls, three tools and one repair per turn. The merchant’s words never become permission to approve an export. We have 61 passing regression tests and seven visible guided probes; those are not a claim of live-model accuracy.</a:t>
             </a:r>
           </a:p>
           <a:p xmlns:a="http://schemas.openxmlformats.org/drawingml/2006/main">
@@ -861,7 +1951,7 @@
           </a:p>
           <a:p xmlns:a="http://schemas.openxmlformats.org/drawingml/2006/main">
             <a:r>
-              <a:t>Sources: lib/agents/graph.ts, config.ts, reasoning.ts, evaluation.ts, lib/interview.ts, tests/, docs/VOICE-UPGRADE.md. Observed test run: 56/56 passed.</a:t>
+              <a:t>Sources: lib/agents/graph.ts, config.ts, reasoning.ts, evaluation.ts, lib/interview.ts, tests/, docs/VOICE-UPGRADE.md. Observed test run: 61/61 passed.</a:t>
             </a:r>
           </a:p>
           <a:p xmlns:a="http://schemas.openxmlformats.org/drawingml/2006/main">
@@ -877,6 +1967,56 @@
           <a:p xmlns:a="http://schemas.openxmlformats.org/drawingml/2006/main">
             <a:r>
               <a:t>Public repository: https://github.com/gowtham66867/merchantlens-paytm (voice revision 7a794d2). Local implementation inspected on 18 October 2026. App: https://merchantlens-paytm-412542191970.asia-south1.run.app/ . No affiliation, production deployment within Paytm, or independently verified payment status is implied.</a:t>
+            </a:r>
+          </a:p>
+          <a:p xmlns:a="http://schemas.openxmlformats.org/drawingml/2006/main">
+            <a:r>
+              <a:t/>
+            </a:r>
+          </a:p>
+          <a:p xmlns:a="http://schemas.openxmlformats.org/drawingml/2006/main">
+            <a:r>
+              <a:t>CURRENT SUPPORT EXTENSION</a:t>
+            </a:r>
+          </a:p>
+          <a:p xmlns:a="http://schemas.openxmlformats.org/drawingml/2006/main">
+            <a:r>
+              <a:t>Support history is manually entered, bounded to 20 notes, source-linked and carried into the current interview graph. Edits and human requests reset approvals. Two unresolved entries recommend a human review; no stage completion is required to request it. Public checkpoints are blocked. No Paytm records or ticket API is connected. Internal exports include history; anonymized exports omit free-text details. See https://github.com/gowtham66867/merchantlens-paytm/blob/main/docs/TECHNICAL-FEEDBACK.md and docs/SUPPORT-JOURNEY.md.</a:t>
+            </a:r>
+          </a:p>
+          <a:p xmlns:a="http://schemas.openxmlformats.org/drawingml/2006/main">
+            <a:r>
+              <a:t/>
+            </a:r>
+          </a:p>
+          <a:p xmlns:a="http://schemas.openxmlformats.org/drawingml/2006/main">
+            <a:r>
+              <a:t>PRIMARY CONTEXT</a:t>
+            </a:r>
+          </a:p>
+          <a:p xmlns:a="http://schemas.openxmlformats.org/drawingml/2006/main">
+            <a:r>
+              <a:t>Paytm AI Soundbox: https://paytm.com/document/ir/press-release/AI-SB.pdf ; merchant channels: https://business.paytmpayments.com/contact-us . Published consumer grievance levels are not evidence of the five internal merchant-support layers. Repository implementation through c91a439, 18 October 2026.</a:t>
+            </a:r>
+          </a:p>
+          <a:p xmlns:a="http://schemas.openxmlformats.org/drawingml/2006/main">
+            <a:r>
+              <a:t/>
+            </a:r>
+          </a:p>
+          <a:p xmlns:a="http://schemas.openxmlformats.org/drawingml/2006/main">
+            <a:r>
+              <a:t>OPEN ITEMS</a:t>
+            </a:r>
+          </a:p>
+          <a:p xmlns:a="http://schemas.openxmlformats.org/drawingml/2006/main">
+            <a:r>
+              <a:t>Confirm the actual support layers and authorized APIs. Persist the spoken-response preference after refresh. Benchmark real multilingual/noisy audio and live Gemini interview quality. Complete production identity, privacy/security, retention, distributed abuse/cost controls and a baseline pilot. Existing backup video is a historical typed-synthetic walkthrough.</a:t>
+            </a:r>
+          </a:p>
+          <a:p xmlns:a="http://schemas.openxmlformats.org/drawingml/2006/main">
+            <a:r>
+              <a:t/>
             </a:r>
           </a:p>
         </p:txBody>
@@ -946,6 +2086,116 @@
           <a:lstStyle xmlns:a="http://schemas.openxmlformats.org/drawingml/2006/main"/>
           <a:p xmlns:a="http://schemas.openxmlformats.org/drawingml/2006/main">
             <a:r>
+              <a:t>PRESENTATION STORY — 35–45 seconds</a:t>
+            </a:r>
+          </a:p>
+          <a:p xmlns:a="http://schemas.openxmlformats.org/drawingml/2006/main">
+            <a:r>
+              <a:t>The support journey records previous checks and their reported outcomes. Two unresolved entries recommend human review, and the merchant can request human review immediately without completing five gates. Internal exports include that history after approval. No ticket is sent. A proposed ten-merchant pilot should measure repeat questioning, reviewed handoff time, usefulness, corrections and total cost. Real integration needs Paytm’s stage map, identity, authorized records and case APIs.</a:t>
+            </a:r>
+          </a:p>
+          <a:p xmlns:a="http://schemas.openxmlformats.org/drawingml/2006/main">
+            <a:r>
+              <a:t/>
+            </a:r>
+          </a:p>
+          <a:p xmlns:a="http://schemas.openxmlformats.org/drawingml/2006/main">
+            <a:r>
+              <a:t>TECHNICAL FEEDBACK REGISTER — slide 5</a:t>
+            </a:r>
+          </a:p>
+          <a:p xmlns:a="http://schemas.openxmlformats.org/drawingml/2006/main">
+            <a:r>
+              <a:t>The five-layer statement is user-reported Paytm leader feedback. Other entries are user requirements/questions, observed failures or engineering responses, not judge quotations.</a:t>
+            </a:r>
+          </a:p>
+          <a:p xmlns:a="http://schemas.openxmlformats.org/drawingml/2006/main">
+            <a:r>
+              <a:t/>
+            </a:r>
+          </a:p>
+          <a:p xmlns:a="http://schemas.openxmlformats.org/drawingml/2006/main">
+            <a:r>
+              <a:t>F32 — Keep access to human review</a:t>
+            </a:r>
+          </a:p>
+          <a:p xmlns:a="http://schemas.openxmlformats.org/drawingml/2006/main">
+            <a:r>
+              <a:t>Source: Engineering response to F30</a:t>
+            </a:r>
+          </a:p>
+          <a:p xmlns:a="http://schemas.openxmlformats.org/drawingml/2006/main">
+            <a:r>
+              <a:t>Incorporated: Human review can be requested with zero completed stages or payment evidence; completing all five is never required</a:t>
+            </a:r>
+          </a:p>
+          <a:p xmlns:a="http://schemas.openxmlformats.org/drawingml/2006/main">
+            <a:r>
+              <a:t>Status / limitation: Local request/flag only; no ticket sent and no human connected by the prototype</a:t>
+            </a:r>
+          </a:p>
+          <a:p xmlns:a="http://schemas.openxmlformats.org/drawingml/2006/main">
+            <a:r>
+              <a:t/>
+            </a:r>
+          </a:p>
+          <a:p xmlns:a="http://schemas.openxmlformats.org/drawingml/2006/main">
+            <a:r>
+              <a:t>F33 — Quantify Paytm ROI</a:t>
+            </a:r>
+          </a:p>
+          <a:p xmlns:a="http://schemas.openxmlformats.org/drawingml/2006/main">
+            <a:r>
+              <a:t>Source: User</a:t>
+            </a:r>
+          </a:p>
+          <a:p xmlns:a="http://schemas.openxmlformats.org/drawingml/2006/main">
+            <a:r>
+              <a:t>Incorporated: Proposed 10-merchant feasibility pilot; compare time to reviewer-accepted brief, repeat questions/contacts, routing agreement, corrections, voice failures, review effort and cost</a:t>
+            </a:r>
+          </a:p>
+          <a:p xmlns:a="http://schemas.openxmlformats.org/drawingml/2006/main">
+            <a:r>
+              <a:t>Status / limitation: Savings and deflection are unmeasured; do not double-count time/contact benefits</a:t>
+            </a:r>
+          </a:p>
+          <a:p xmlns:a="http://schemas.openxmlformats.org/drawingml/2006/main">
+            <a:r>
+              <a:t/>
+            </a:r>
+          </a:p>
+          <a:p xmlns:a="http://schemas.openxmlformats.org/drawingml/2006/main">
+            <a:r>
+              <a:t>F34 — Extend the prototype into Paytm systems</a:t>
+            </a:r>
+          </a:p>
+          <a:p xmlns:a="http://schemas.openxmlformats.org/drawingml/2006/main">
+            <a:r>
+              <a:t>Source: User</a:t>
+            </a:r>
+          </a:p>
+          <a:p xmlns:a="http://schemas.openxmlformats.org/drawingml/2006/main">
+            <a:r>
+              <a:t>Incorporated: Proposed authorized read-only history/payment/settlement/device adapters, separate source provenance, reviewed/idempotent case creation, tenant isolation, retention, monitoring and real-language evaluation</a:t>
+            </a:r>
+          </a:p>
+          <a:p xmlns:a="http://schemas.openxmlformats.org/drawingml/2006/main">
+            <a:r>
+              <a:t>Status / limitation: No Paytm API connection, live import, ticket submission, payment verification, refund or device repair</a:t>
+            </a:r>
+          </a:p>
+          <a:p xmlns:a="http://schemas.openxmlformats.org/drawingml/2006/main">
+            <a:r>
+              <a:t/>
+            </a:r>
+          </a:p>
+          <a:p xmlns:a="http://schemas.openxmlformats.org/drawingml/2006/main">
+            <a:r>
+              <a:t>DETAILED IMPLEMENTATION REFERENCE</a:t>
+            </a:r>
+          </a:p>
+          <a:p xmlns:a="http://schemas.openxmlformats.org/drawingml/2006/main">
+            <a:r>
               <a:t>PRESENTATION — 40 SECONDS</a:t>
             </a:r>
           </a:p>
@@ -1042,6 +2292,56 @@
           <a:p xmlns:a="http://schemas.openxmlformats.org/drawingml/2006/main">
             <a:r>
               <a:t>Public repository: https://github.com/gowtham66867/merchantlens-paytm (voice revision 7a794d2). Local implementation inspected on 18 October 2026. App: https://merchantlens-paytm-412542191970.asia-south1.run.app/ . No affiliation, production deployment within Paytm, or independently verified payment status is implied.</a:t>
+            </a:r>
+          </a:p>
+          <a:p xmlns:a="http://schemas.openxmlformats.org/drawingml/2006/main">
+            <a:r>
+              <a:t/>
+            </a:r>
+          </a:p>
+          <a:p xmlns:a="http://schemas.openxmlformats.org/drawingml/2006/main">
+            <a:r>
+              <a:t>CURRENT SUPPORT EXTENSION</a:t>
+            </a:r>
+          </a:p>
+          <a:p xmlns:a="http://schemas.openxmlformats.org/drawingml/2006/main">
+            <a:r>
+              <a:t>Support history is manually entered, bounded to 20 notes, source-linked and carried into the current interview graph. Edits and human requests reset approvals. Two unresolved entries recommend a human review; no stage completion is required to request it. Public checkpoints are blocked. No Paytm records or ticket API is connected. Internal exports include history; anonymized exports omit free-text details. See https://github.com/gowtham66867/merchantlens-paytm/blob/main/docs/TECHNICAL-FEEDBACK.md and docs/SUPPORT-JOURNEY.md.</a:t>
+            </a:r>
+          </a:p>
+          <a:p xmlns:a="http://schemas.openxmlformats.org/drawingml/2006/main">
+            <a:r>
+              <a:t/>
+            </a:r>
+          </a:p>
+          <a:p xmlns:a="http://schemas.openxmlformats.org/drawingml/2006/main">
+            <a:r>
+              <a:t>PRIMARY CONTEXT</a:t>
+            </a:r>
+          </a:p>
+          <a:p xmlns:a="http://schemas.openxmlformats.org/drawingml/2006/main">
+            <a:r>
+              <a:t>Paytm AI Soundbox: https://paytm.com/document/ir/press-release/AI-SB.pdf ; merchant channels: https://business.paytmpayments.com/contact-us . Published consumer grievance levels are not evidence of the five internal merchant-support layers. Repository implementation through c91a439, 18 October 2026.</a:t>
+            </a:r>
+          </a:p>
+          <a:p xmlns:a="http://schemas.openxmlformats.org/drawingml/2006/main">
+            <a:r>
+              <a:t/>
+            </a:r>
+          </a:p>
+          <a:p xmlns:a="http://schemas.openxmlformats.org/drawingml/2006/main">
+            <a:r>
+              <a:t>OPEN ITEMS</a:t>
+            </a:r>
+          </a:p>
+          <a:p xmlns:a="http://schemas.openxmlformats.org/drawingml/2006/main">
+            <a:r>
+              <a:t>Confirm the actual support layers and authorized APIs. Persist the spoken-response preference after refresh. Benchmark real multilingual/noisy audio and live Gemini interview quality. Complete production identity, privacy/security, retention, distributed abuse/cost controls and a baseline pilot. Existing backup video is a historical typed-synthetic walkthrough.</a:t>
+            </a:r>
+          </a:p>
+          <a:p xmlns:a="http://schemas.openxmlformats.org/drawingml/2006/main">
+            <a:r>
+              <a:t/>
             </a:r>
           </a:p>
         </p:txBody>
@@ -3484,12 +4784,12 @@
   </p:cSld>
   <p:clrMap bg1="lt1" tx1="dk1" bg2="lt2" tx2="dk2" accent1="accent1" accent2="accent2" accent3="accent3" accent4="accent4" accent5="accent5" accent6="accent6" hlink="hlink" folHlink="folHlink"/>
   <p:sldLayoutIdLst>
-    <p:sldLayoutId xmlns:r="http://schemas.openxmlformats.org/officeDocument/2006/relationships" id="2147483649" r:id="R4bfc39505c0b4bb2"/>
-    <p:sldLayoutId xmlns:r="http://schemas.openxmlformats.org/officeDocument/2006/relationships" id="2147483650" r:id="R847176f5caf9475c"/>
-    <p:sldLayoutId xmlns:r="http://schemas.openxmlformats.org/officeDocument/2006/relationships" id="2147483651" r:id="Re7122a2e2f414f6c"/>
-    <p:sldLayoutId xmlns:r="http://schemas.openxmlformats.org/officeDocument/2006/relationships" id="2147483652" r:id="Raa162c1197d9418b"/>
-    <p:sldLayoutId xmlns:r="http://schemas.openxmlformats.org/officeDocument/2006/relationships" id="2147483653" r:id="R5b5425367c8b47a2"/>
-    <p:sldLayoutId xmlns:r="http://schemas.openxmlformats.org/officeDocument/2006/relationships" id="2147483654" r:id="R31618c7adba24af6"/>
+    <p:sldLayoutId xmlns:r="http://schemas.openxmlformats.org/officeDocument/2006/relationships" id="2147483649" r:id="R4af5f0b18afd4af5"/>
+    <p:sldLayoutId xmlns:r="http://schemas.openxmlformats.org/officeDocument/2006/relationships" id="2147483650" r:id="Re3a463353d3d4e46"/>
+    <p:sldLayoutId xmlns:r="http://schemas.openxmlformats.org/officeDocument/2006/relationships" id="2147483651" r:id="R9ab1d60f60ed41c0"/>
+    <p:sldLayoutId xmlns:r="http://schemas.openxmlformats.org/officeDocument/2006/relationships" id="2147483652" r:id="Rc018d9c683864e72"/>
+    <p:sldLayoutId xmlns:r="http://schemas.openxmlformats.org/officeDocument/2006/relationships" id="2147483653" r:id="Rc870007d70144032"/>
+    <p:sldLayoutId xmlns:r="http://schemas.openxmlformats.org/officeDocument/2006/relationships" id="2147483654" r:id="R3ecec37450f84236"/>
   </p:sldLayoutIdLst>
   <p:txStyles>
     <p:titleStyle>
@@ -4362,7 +5662,7 @@
                 <a:ea typeface="Helvetica Neue"/>
                 <a:cs typeface="Helvetica Neue"/>
               </a:rPr>
-              <a:t>Voice interviews that create verifiable problem briefs</a:t>
+              <a:t>One merchant’s story, carried across support touchpoints</a:t>
             </a:r>
           </a:p>
         </p:txBody>
@@ -4694,7 +5994,7 @@
                 <a:ea typeface="Helvetica Neue"/>
                 <a:cs typeface="Helvetica Neue"/>
               </a:rPr>
-              <a:t>The problem is an unclear account — and no reliable way to check its interpretation</a:t>
+              <a:t>Leader feedback: five layers before human support</a:t>
             </a:r>
           </a:p>
         </p:txBody>
@@ -4860,7 +6160,7 @@
                 <a:ea typeface="Helvetica Neue"/>
                 <a:cs typeface="Helvetica Neue"/>
               </a:rPr>
-              <a:t>Merchant conversations mix symptoms, estimates and assumptions. Operations teams need a useful brief with each observation linked to the merchant’s words and each unknown left visible.</a:t>
+              <a:t>Design hypothesis: useful context should survive every touchpoint. Capture what was tried, retain the merchant’s evidence and make unresolved questions clear to the next reviewer.</a:t>
             </a:r>
           </a:p>
         </p:txBody>
@@ -5026,7 +6326,7 @@
                 <a:ea typeface="Helvetica Neue"/>
                 <a:cs typeface="Helvetica Neue"/>
               </a:rPr>
-              <a:t>Business case: Soundbox and payment-confirmation intake for Paytm merchant operations</a:t>
+              <a:t>Technical response: source-linked history, bounded agents and reviewed handoffs</a:t>
             </a:r>
           </a:p>
         </p:txBody>
@@ -5072,6 +6372,7 @@
               </a:defRPr>
             </a:defPPr>
             <a:lvl1pPr>
+              <a:buNone/>
               <a:defRPr sz="1725" b="0">
                 <a:solidFill>
                   <a:srgbClr val="B9D0DE"/>
@@ -5082,6 +6383,7 @@
               </a:defRPr>
             </a:lvl1pPr>
             <a:lvl2pPr>
+              <a:buNone/>
               <a:defRPr sz="1725" b="0">
                 <a:solidFill>
                   <a:srgbClr val="B9D0DE"/>
@@ -5092,6 +6394,7 @@
               </a:defRPr>
             </a:lvl2pPr>
             <a:lvl3pPr>
+              <a:buNone/>
               <a:defRPr sz="1725" b="0">
                 <a:solidFill>
                   <a:srgbClr val="B9D0DE"/>
@@ -5102,6 +6405,7 @@
               </a:defRPr>
             </a:lvl3pPr>
             <a:lvl4pPr>
+              <a:buNone/>
               <a:defRPr sz="1725" b="0">
                 <a:solidFill>
                   <a:srgbClr val="B9D0DE"/>
@@ -5112,6 +6416,7 @@
               </a:defRPr>
             </a:lvl4pPr>
             <a:lvl5pPr>
+              <a:buNone/>
               <a:defRPr sz="1725" b="0">
                 <a:solidFill>
                   <a:srgbClr val="B9D0DE"/>
@@ -5122,6 +6427,7 @@
               </a:defRPr>
             </a:lvl5pPr>
             <a:lvl6pPr>
+              <a:buNone/>
               <a:defRPr sz="1725" b="0">
                 <a:solidFill>
                   <a:srgbClr val="B9D0DE"/>
@@ -5132,6 +6438,7 @@
               </a:defRPr>
             </a:lvl6pPr>
             <a:lvl7pPr>
+              <a:buNone/>
               <a:defRPr sz="1725" b="0">
                 <a:solidFill>
                   <a:srgbClr val="B9D0DE"/>
@@ -5142,6 +6449,7 @@
               </a:defRPr>
             </a:lvl7pPr>
             <a:lvl8pPr>
+              <a:buNone/>
               <a:defRPr sz="1725" b="0">
                 <a:solidFill>
                   <a:srgbClr val="B9D0DE"/>
@@ -5152,6 +6460,7 @@
               </a:defRPr>
             </a:lvl8pPr>
             <a:lvl9pPr>
+              <a:buNone/>
               <a:defRPr sz="1725" b="0">
                 <a:solidFill>
                   <a:srgbClr val="B9D0DE"/>
@@ -5164,6 +6473,7 @@
           </a:lstStyle>
           <a:p xmlns:a="http://schemas.openxmlformats.org/drawingml/2006/main">
             <a:pPr>
+              <a:buNone/>
               <a:defRPr sz="1725" b="0">
                 <a:solidFill>
                   <a:srgbClr val="B9D0DE"/>
@@ -5228,6 +6538,7 @@
               </a:defRPr>
             </a:defPPr>
             <a:lvl1pPr>
+              <a:buNone/>
               <a:defRPr sz="1275" b="0">
                 <a:solidFill>
                   <a:srgbClr val="B9D0DE"/>
@@ -5238,6 +6549,7 @@
               </a:defRPr>
             </a:lvl1pPr>
             <a:lvl2pPr>
+              <a:buNone/>
               <a:defRPr sz="1275" b="0">
                 <a:solidFill>
                   <a:srgbClr val="B9D0DE"/>
@@ -5248,6 +6560,7 @@
               </a:defRPr>
             </a:lvl2pPr>
             <a:lvl3pPr>
+              <a:buNone/>
               <a:defRPr sz="1275" b="0">
                 <a:solidFill>
                   <a:srgbClr val="B9D0DE"/>
@@ -5258,6 +6571,7 @@
               </a:defRPr>
             </a:lvl3pPr>
             <a:lvl4pPr>
+              <a:buNone/>
               <a:defRPr sz="1275" b="0">
                 <a:solidFill>
                   <a:srgbClr val="B9D0DE"/>
@@ -5268,6 +6582,7 @@
               </a:defRPr>
             </a:lvl4pPr>
             <a:lvl5pPr>
+              <a:buNone/>
               <a:defRPr sz="1275" b="0">
                 <a:solidFill>
                   <a:srgbClr val="B9D0DE"/>
@@ -5278,6 +6593,7 @@
               </a:defRPr>
             </a:lvl5pPr>
             <a:lvl6pPr>
+              <a:buNone/>
               <a:defRPr sz="1275" b="0">
                 <a:solidFill>
                   <a:srgbClr val="B9D0DE"/>
@@ -5288,6 +6604,7 @@
               </a:defRPr>
             </a:lvl6pPr>
             <a:lvl7pPr>
+              <a:buNone/>
               <a:defRPr sz="1275" b="0">
                 <a:solidFill>
                   <a:srgbClr val="B9D0DE"/>
@@ -5298,6 +6615,7 @@
               </a:defRPr>
             </a:lvl7pPr>
             <a:lvl8pPr>
+              <a:buNone/>
               <a:defRPr sz="1275" b="0">
                 <a:solidFill>
                   <a:srgbClr val="B9D0DE"/>
@@ -5308,6 +6626,7 @@
               </a:defRPr>
             </a:lvl8pPr>
             <a:lvl9pPr>
+              <a:buNone/>
               <a:defRPr sz="1275" b="0">
                 <a:solidFill>
                   <a:srgbClr val="B9D0DE"/>
@@ -5320,6 +6639,7 @@
           </a:lstStyle>
           <a:p xmlns:a="http://schemas.openxmlformats.org/drawingml/2006/main">
             <a:pPr>
+              <a:buNone/>
               <a:defRPr sz="1275" b="0">
                 <a:solidFill>
                   <a:srgbClr val="B9D0DE"/>
@@ -5338,7 +6658,7 @@
                 <a:ea typeface="Helvetica Neue"/>
                 <a:cs typeface="Helvetica Neue"/>
               </a:rPr>
-              <a:t>Illustrative ₹2,400 scenario. Source traceability does not independently verify a transaction.</a:t>
+              <a:t>Five layers: user-reported leader feedback; exact mapping unverified. No Paytm APIs connected.</a:t>
             </a:r>
           </a:p>
         </p:txBody>
@@ -5533,7 +6853,7 @@
                 <a:ea typeface="Helvetica Neue"/>
                 <a:cs typeface="Helvetica Neue"/>
               </a:rPr>
-              <a:t>Clarification, context and verifiability</a:t>
+              <a:t>Evidence that survives the handoff</a:t>
             </a:r>
           </a:p>
         </p:txBody>
@@ -6933,7 +8253,7 @@
                 <a:ea typeface="Helvetica Neue"/>
                 <a:cs typeface="Helvetica Neue"/>
               </a:rPr>
-              <a:t>What the reviewed brief contains</a:t>
+              <a:t>One case across touchpoints</a:t>
             </a:r>
           </a:p>
         </p:txBody>
@@ -7099,7 +8419,7 @@
                 <a:ea typeface="Helvetica Neue"/>
                 <a:cs typeface="Helvetica Neue"/>
               </a:rPr>
-              <a:t>Problem and operating context</a:t>
+              <a:t>History and operating context</a:t>
             </a:r>
           </a:p>
         </p:txBody>
@@ -7265,7 +8585,7 @@
                 <a:ea typeface="Helvetica Neue"/>
                 <a:cs typeface="Helvetica Neue"/>
               </a:rPr>
-              <a:t>Symptom, affected users, frequency, impact, workaround, prior attempts, constraints and desired outcome.</a:t>
+              <a:t>Symptom, workflow, earlier checks, channels and reported outcomes; unresolved questions stay attached.</a:t>
             </a:r>
           </a:p>
         </p:txBody>
@@ -7597,7 +8917,7 @@
                 <a:ea typeface="Helvetica Neue"/>
                 <a:cs typeface="Helvetica Neue"/>
               </a:rPr>
-              <a:t>Observation → exact quote → turn ID. Estimates, corrections and unresolved questions stay visible.</a:t>
+              <a:t>Observation → received quote → turn ID. Context includes prior facts, corrections, language and curated sources.</a:t>
             </a:r>
           </a:p>
         </p:txBody>
@@ -7929,7 +9249,7 @@
                 <a:ea typeface="Helvetica Neue"/>
                 <a:cs typeface="Helvetica Neue"/>
               </a:rPr>
-              <a:t>Correct or redact details; approve internal and anonymized versions separately; export JSON or Markdown.</a:t>
+              <a:t>Edits reset both approvals. Internal handoffs retain history; anonymized exports omit free-text support details.</a:t>
             </a:r>
           </a:p>
         </p:txBody>
@@ -8141,6 +9461,7 @@
               </a:defRPr>
             </a:defPPr>
             <a:lvl1pPr>
+              <a:buNone/>
               <a:defRPr sz="1200" b="0">
                 <a:solidFill>
                   <a:srgbClr val="526B7C"/>
@@ -8151,6 +9472,7 @@
               </a:defRPr>
             </a:lvl1pPr>
             <a:lvl2pPr>
+              <a:buNone/>
               <a:defRPr sz="1200" b="0">
                 <a:solidFill>
                   <a:srgbClr val="526B7C"/>
@@ -8161,6 +9483,7 @@
               </a:defRPr>
             </a:lvl2pPr>
             <a:lvl3pPr>
+              <a:buNone/>
               <a:defRPr sz="1200" b="0">
                 <a:solidFill>
                   <a:srgbClr val="526B7C"/>
@@ -8171,6 +9494,7 @@
               </a:defRPr>
             </a:lvl3pPr>
             <a:lvl4pPr>
+              <a:buNone/>
               <a:defRPr sz="1200" b="0">
                 <a:solidFill>
                   <a:srgbClr val="526B7C"/>
@@ -8181,6 +9505,7 @@
               </a:defRPr>
             </a:lvl4pPr>
             <a:lvl5pPr>
+              <a:buNone/>
               <a:defRPr sz="1200" b="0">
                 <a:solidFill>
                   <a:srgbClr val="526B7C"/>
@@ -8191,6 +9516,7 @@
               </a:defRPr>
             </a:lvl5pPr>
             <a:lvl6pPr>
+              <a:buNone/>
               <a:defRPr sz="1200" b="0">
                 <a:solidFill>
                   <a:srgbClr val="526B7C"/>
@@ -8201,6 +9527,7 @@
               </a:defRPr>
             </a:lvl6pPr>
             <a:lvl7pPr>
+              <a:buNone/>
               <a:defRPr sz="1200" b="0">
                 <a:solidFill>
                   <a:srgbClr val="526B7C"/>
@@ -8211,6 +9538,7 @@
               </a:defRPr>
             </a:lvl7pPr>
             <a:lvl8pPr>
+              <a:buNone/>
               <a:defRPr sz="1200" b="0">
                 <a:solidFill>
                   <a:srgbClr val="526B7C"/>
@@ -8221,6 +9549,7 @@
               </a:defRPr>
             </a:lvl8pPr>
             <a:lvl9pPr>
+              <a:buNone/>
               <a:defRPr sz="1200" b="0">
                 <a:solidFill>
                   <a:srgbClr val="526B7C"/>
@@ -8233,6 +9562,7 @@
           </a:lstStyle>
           <a:p xmlns:a="http://schemas.openxmlformats.org/drawingml/2006/main">
             <a:pPr>
+              <a:buNone/>
               <a:defRPr sz="1200" b="0">
                 <a:solidFill>
                   <a:srgbClr val="526B7C"/>
@@ -8297,6 +9627,7 @@
               </a:defRPr>
             </a:defPPr>
             <a:lvl1pPr>
+              <a:buNone/>
               <a:defRPr sz="1200" b="0">
                 <a:solidFill>
                   <a:srgbClr val="526B7C"/>
@@ -8307,6 +9638,7 @@
               </a:defRPr>
             </a:lvl1pPr>
             <a:lvl2pPr>
+              <a:buNone/>
               <a:defRPr sz="1200" b="0">
                 <a:solidFill>
                   <a:srgbClr val="526B7C"/>
@@ -8317,6 +9649,7 @@
               </a:defRPr>
             </a:lvl2pPr>
             <a:lvl3pPr>
+              <a:buNone/>
               <a:defRPr sz="1200" b="0">
                 <a:solidFill>
                   <a:srgbClr val="526B7C"/>
@@ -8327,6 +9660,7 @@
               </a:defRPr>
             </a:lvl3pPr>
             <a:lvl4pPr>
+              <a:buNone/>
               <a:defRPr sz="1200" b="0">
                 <a:solidFill>
                   <a:srgbClr val="526B7C"/>
@@ -8337,6 +9671,7 @@
               </a:defRPr>
             </a:lvl4pPr>
             <a:lvl5pPr>
+              <a:buNone/>
               <a:defRPr sz="1200" b="0">
                 <a:solidFill>
                   <a:srgbClr val="526B7C"/>
@@ -8347,6 +9682,7 @@
               </a:defRPr>
             </a:lvl5pPr>
             <a:lvl6pPr>
+              <a:buNone/>
               <a:defRPr sz="1200" b="0">
                 <a:solidFill>
                   <a:srgbClr val="526B7C"/>
@@ -8357,6 +9693,7 @@
               </a:defRPr>
             </a:lvl6pPr>
             <a:lvl7pPr>
+              <a:buNone/>
               <a:defRPr sz="1200" b="0">
                 <a:solidFill>
                   <a:srgbClr val="526B7C"/>
@@ -8367,6 +9704,7 @@
               </a:defRPr>
             </a:lvl7pPr>
             <a:lvl8pPr>
+              <a:buNone/>
               <a:defRPr sz="1200" b="0">
                 <a:solidFill>
                   <a:srgbClr val="526B7C"/>
@@ -8377,6 +9715,7 @@
               </a:defRPr>
             </a:lvl8pPr>
             <a:lvl9pPr>
+              <a:buNone/>
               <a:defRPr sz="1200" b="0">
                 <a:solidFill>
                   <a:srgbClr val="526B7C"/>
@@ -8389,6 +9728,7 @@
           </a:lstStyle>
           <a:p xmlns:a="http://schemas.openxmlformats.org/drawingml/2006/main">
             <a:pPr>
+              <a:buNone/>
               <a:defRPr sz="1200" b="0">
                 <a:solidFill>
                   <a:srgbClr val="526B7C"/>
@@ -8602,7 +9942,7 @@
                 <a:ea typeface="Helvetica Neue"/>
                 <a:cs typeface="Helvetica Neue"/>
               </a:rPr>
-              <a:t>Voice and runtime architecture</a:t>
+              <a:t>Voice recovery, codecs and runtime</a:t>
             </a:r>
           </a:p>
         </p:txBody>
@@ -9100,7 +10440,7 @@
                 <a:ea typeface="Helvetica Neue"/>
                 <a:cs typeface="Helvetica Neue"/>
               </a:rPr>
-              <a:t>Voice controls</a:t>
+              <a:t>Voice feedback incorporated</a:t>
             </a:r>
           </a:p>
         </p:txBody>
@@ -9266,7 +10606,7 @@
                 <a:ea typeface="Helvetica Neue"/>
                 <a:cs typeface="Helvetica Neue"/>
               </a:rPr>
-              <a:t>Echo cancellation, noise suppression and gain control</a:t>
+              <a:t>MediaRecorder replaces failed browser recognition</a:t>
             </a:r>
           </a:p>
           <a:p xmlns:a="http://schemas.openxmlformats.org/drawingml/2006/main">
@@ -9290,55 +10630,7 @@
                 <a:ea typeface="Helvetica Neue"/>
                 <a:cs typeface="Helvetica Neue"/>
               </a:rPr>
-              <a:t>Local energy detection; 200 ms of speech ignores clicks</a:t>
-            </a:r>
-          </a:p>
-          <a:p xmlns:a="http://schemas.openxmlformats.org/drawingml/2006/main">
-            <a:pPr>
-              <a:buNone/>
-              <a:defRPr sz="1725" b="0">
-                <a:solidFill>
-                  <a:srgbClr val="102F43"/>
-                </a:solidFill>
-                <a:latin typeface="Helvetica Neue"/>
-                <a:ea typeface="Helvetica Neue"/>
-                <a:cs typeface="Helvetica Neue"/>
-              </a:defRPr>
-            </a:pPr>
-            <a:r>
-              <a:rPr sz="1725" b="0">
-                <a:solidFill>
-                  <a:srgbClr val="102F43"/>
-                </a:solidFill>
-                <a:latin typeface="Helvetica Neue"/>
-                <a:ea typeface="Helvetica Neue"/>
-                <a:cs typeface="Helvetica Neue"/>
-              </a:rPr>
-              <a:t>Pause: 1.2 s / 2 s default / 3.5 s thinking time</a:t>
-            </a:r>
-          </a:p>
-          <a:p xmlns:a="http://schemas.openxmlformats.org/drawingml/2006/main">
-            <a:pPr>
-              <a:buNone/>
-              <a:defRPr sz="1725" b="0">
-                <a:solidFill>
-                  <a:srgbClr val="102F43"/>
-                </a:solidFill>
-                <a:latin typeface="Helvetica Neue"/>
-                <a:ea typeface="Helvetica Neue"/>
-                <a:cs typeface="Helvetica Neue"/>
-              </a:defRPr>
-            </a:pPr>
-            <a:r>
-              <a:rPr sz="1725" b="0">
-                <a:solidFill>
-                  <a:srgbClr val="102F43"/>
-                </a:solidFill>
-                <a:latin typeface="Helvetica Neue"/>
-                <a:ea typeface="Helvetica Neue"/>
-                <a:cs typeface="Helvetica Neue"/>
-              </a:rPr>
-              <a:t>No speech for 10 s: discard; recording limit: 45 s</a:t>
+              <a:t>Local VAD: 1.2 / 2 / 3.5 s; manual Stop available</a:t>
             </a:r>
           </a:p>
           <a:p xmlns:a="http://schemas.openxmlformats.org/drawingml/2006/main">
@@ -9386,7 +10678,31 @@
                 <a:ea typeface="Helvetica Neue"/>
                 <a:cs typeface="Helvetica Neue"/>
               </a:rPr>
-              <a:t>Gemini natural playback; device voice fallback</a:t>
+              <a:t>Opus/WebM preferred; tested WAV: PCM, 24 kHz mono</a:t>
+            </a:r>
+          </a:p>
+          <a:p xmlns:a="http://schemas.openxmlformats.org/drawingml/2006/main">
+            <a:pPr>
+              <a:buNone/>
+              <a:defRPr sz="1725" b="0">
+                <a:solidFill>
+                  <a:srgbClr val="102F43"/>
+                </a:solidFill>
+                <a:latin typeface="Helvetica Neue"/>
+                <a:ea typeface="Helvetica Neue"/>
+                <a:cs typeface="Helvetica Neue"/>
+              </a:defRPr>
+            </a:pPr>
+            <a:r>
+              <a:rPr sz="1725" b="0">
+                <a:solidFill>
+                  <a:srgbClr val="102F43"/>
+                </a:solidFill>
+                <a:latin typeface="Helvetica Neue"/>
+                <a:ea typeface="Helvetica Neue"/>
+                <a:cs typeface="Helvetica Neue"/>
+              </a:rPr>
+              <a:t>Gemini transcription + Kore TTS; device fallback</a:t>
             </a:r>
           </a:p>
         </p:txBody>
@@ -9778,7 +11094,7 @@
           <a:bodyPr xmlns:a="http://schemas.openxmlformats.org/drawingml/2006/main" lIns="0" tIns="0" rIns="0" bIns="0" anchor="t"/>
           <a:lstStyle xmlns:a="http://schemas.openxmlformats.org/drawingml/2006/main">
             <a:defPPr>
-              <a:defRPr sz="1425" b="0">
+              <a:defRPr sz="1350" b="0">
                 <a:solidFill>
                   <a:srgbClr val="526B7C"/>
                 </a:solidFill>
@@ -9900,7 +11216,7 @@
               </a:defRPr>
             </a:pPr>
             <a:r>
-              <a:rPr sz="1425" b="0">
+              <a:rPr sz="1350" b="0">
                 <a:solidFill>
                   <a:srgbClr val="526B7C"/>
                 </a:solidFill>
@@ -9908,7 +11224,7 @@
                 <a:ea typeface="Helvetica Neue"/>
                 <a:cs typeface="Helvetica Neue"/>
               </a:rPr>
-              <a:t>Deployed voice controls; existing partial human interview</a:t>
+              <a:t>Playback recovered after enabling spoken responses</a:t>
             </a:r>
           </a:p>
         </p:txBody>
@@ -9918,7 +11234,7 @@
           <p:cNvPr id="9" name="">
             <a:extLst xmlns:a="http://schemas.openxmlformats.org/drawingml/2006/main">
               <a:ext uri="{FF2B5EF4-FFF2-40B4-BE49-F238E27FC236}">
-                <a16:creationId xmlns:a16="http://schemas.microsoft.com/office/drawing/2014/main" id="{2DDB8482-B75D-45DB-AA87-2184AA340E63}"/>
+                <a16:creationId xmlns:a16="http://schemas.microsoft.com/office/drawing/2014/main" id="{D023D4C0-E223-4D67-848A-C4A6FB7B9B4B}"/>
               </a:ext>
             </a:extLst>
           </p:cNvPr>
@@ -9928,13 +11244,13 @@
           <p:nvPr/>
         </p:nvPicPr>
         <p:blipFill>
-          <a:blip xmlns:r="http://schemas.openxmlformats.org/officeDocument/2006/relationships" xmlns:a="http://schemas.openxmlformats.org/drawingml/2006/main" r:embed="Rc95aeed5dd554d4e"/>
+          <a:blip xmlns:r="http://schemas.openxmlformats.org/officeDocument/2006/relationships" xmlns:a="http://schemas.openxmlformats.org/drawingml/2006/main" r:embed="R8e838d7a01a84460"/>
           <a:stretch xmlns:a="http://schemas.openxmlformats.org/drawingml/2006/main"/>
         </p:blipFill>
         <p:spPr>
           <a:xfrm xmlns:a="http://schemas.openxmlformats.org/drawingml/2006/main">
-            <a:off x="6502400" y="2505075"/>
-            <a:ext cx="4826000" cy="2714625"/>
+            <a:off x="6502400" y="2541382"/>
+            <a:ext cx="4826000" cy="2642012"/>
           </a:xfrm>
           <a:prstGeom xmlns:a="http://schemas.openxmlformats.org/drawingml/2006/main" prst="rect">
             <a:avLst/>
@@ -9957,8 +11273,8 @@
         </p:nvSpPr>
         <p:spPr>
           <a:xfrm xmlns:a="http://schemas.openxmlformats.org/drawingml/2006/main">
-            <a:off x="6343650" y="5705475"/>
-            <a:ext cx="5143500" cy="628650"/>
+            <a:off x="6343650" y="5629275"/>
+            <a:ext cx="5143500" cy="762000"/>
           </a:xfrm>
           <a:prstGeom xmlns:a="http://schemas.openxmlformats.org/drawingml/2006/main" prst="rect">
             <a:avLst/>
@@ -10102,7 +11418,7 @@
                 <a:ea typeface="Helvetica Neue"/>
                 <a:cs typeface="Helvetica Neue"/>
               </a:rPr>
-              <a:t>Gemini works. OpenAI audio is blocked by exhausted credits; GPT-Live is not connected.</a:t>
+              <a:t>Open: refresh resets speech to off. OpenAI audio lacked credit; GPT-Live is not connected.</a:t>
             </a:r>
           </a:p>
         </p:txBody>
@@ -10629,7 +11945,7 @@
                 <a:ea typeface="Helvetica Neue"/>
                 <a:cs typeface="Helvetica Neue"/>
               </a:rPr>
-              <a:t>Agent harness, guardrails and evaluations</a:t>
+              <a:t>Agent messages, guardrails and evaluation</a:t>
             </a:r>
           </a:p>
         </p:txBody>
@@ -10961,7 +12277,7 @@
                 <a:ea typeface="Helvetica Neue"/>
                 <a:cs typeface="Helvetica Neue"/>
               </a:rPr>
-              <a:t>Extractor → provenance check</a:t>
+              <a:t>Extractor → validated JSON</a:t>
             </a:r>
           </a:p>
         </p:txBody>
@@ -11127,7 +12443,7 @@
                 <a:ea typeface="Helvetica Neue"/>
                 <a:cs typeface="Helvetica Neue"/>
               </a:rPr>
-              <a:t>Proposes observations; code checks exact quotes and source turns before accepting evidence.</a:t>
+              <a:t>Returns topic, value, quote, turn_id and estimated. Code checks source existence and exact received quotes.</a:t>
             </a:r>
           </a:p>
         </p:txBody>
@@ -11293,7 +12609,7 @@
                 <a:ea typeface="Helvetica Neue"/>
                 <a:cs typeface="Helvetica Neue"/>
               </a:rPr>
-              <a:t>Critic + read-only tools in parallel</a:t>
+              <a:t>Critic + tools → merged context</a:t>
             </a:r>
           </a:p>
         </p:txBody>
@@ -11459,7 +12775,7 @@
                 <a:ea typeface="Helvetica Neue"/>
                 <a:cs typeface="Helvetica Neue"/>
               </a:rPr>
-              <a:t>Challenges unsupported claims; retrieves curated context, checks coverage and inspects evidence.</a:t>
+              <a:t>Critic returns rejections and challenges. Allowlisted tools run in parallel; their outputs join before planning.</a:t>
             </a:r>
           </a:p>
         </p:txBody>
@@ -11625,7 +12941,7 @@
                 <a:ea typeface="Helvetica Neue"/>
                 <a:cs typeface="Helvetica Neue"/>
               </a:rPr>
-              <a:t>Planner → policy gate → checkpoint</a:t>
+              <a:t>Planner → code gate → trace</a:t>
             </a:r>
           </a:p>
         </p:txBody>
@@ -11791,7 +13107,7 @@
                 <a:ea typeface="Helvetica Neue"/>
                 <a:cs typeface="Helvetica Neue"/>
               </a:rPr>
-              <a:t>Ranks gaps and contradictions. Code can override a question, request clarification or end for review.</a:t>
+              <a:t>Planner receives ranked candidates, tool results and critic summary. Code can override an unsafe question.</a:t>
             </a:r>
           </a:p>
         </p:txBody>
@@ -12455,7 +13771,7 @@
                 <a:ea typeface="Helvetica Neue"/>
                 <a:cs typeface="Helvetica Neue"/>
               </a:rPr>
-              <a:t>Authority and evidence</a:t>
+              <a:t>Authority, privacy and review</a:t>
             </a:r>
           </a:p>
         </p:txBody>
@@ -12621,7 +13937,7 @@
                 <a:ea typeface="Helvetica Neue"/>
                 <a:cs typeface="Helvetica Neue"/>
               </a:rPr>
-              <a:t>No OTP/PIN requests or payment/refund tools. Merchant text cannot grant export approval. Edits reset approval.</a:t>
+              <a:t>No model-granted approval or financial actions. Edits reset approval; internal and anonymized history are separated.</a:t>
             </a:r>
           </a:p>
         </p:txBody>
@@ -12667,6 +13983,7 @@
               </a:defRPr>
             </a:defPPr>
             <a:lvl1pPr>
+              <a:buNone/>
               <a:defRPr sz="1950" b="1">
                 <a:solidFill>
                   <a:srgbClr val="FFFFFF"/>
@@ -12677,6 +13994,7 @@
               </a:defRPr>
             </a:lvl1pPr>
             <a:lvl2pPr>
+              <a:buNone/>
               <a:defRPr sz="1950" b="1">
                 <a:solidFill>
                   <a:srgbClr val="FFFFFF"/>
@@ -12687,6 +14005,7 @@
               </a:defRPr>
             </a:lvl2pPr>
             <a:lvl3pPr>
+              <a:buNone/>
               <a:defRPr sz="1950" b="1">
                 <a:solidFill>
                   <a:srgbClr val="FFFFFF"/>
@@ -12697,6 +14016,7 @@
               </a:defRPr>
             </a:lvl3pPr>
             <a:lvl4pPr>
+              <a:buNone/>
               <a:defRPr sz="1950" b="1">
                 <a:solidFill>
                   <a:srgbClr val="FFFFFF"/>
@@ -12707,6 +14027,7 @@
               </a:defRPr>
             </a:lvl4pPr>
             <a:lvl5pPr>
+              <a:buNone/>
               <a:defRPr sz="1950" b="1">
                 <a:solidFill>
                   <a:srgbClr val="FFFFFF"/>
@@ -12717,6 +14038,7 @@
               </a:defRPr>
             </a:lvl5pPr>
             <a:lvl6pPr>
+              <a:buNone/>
               <a:defRPr sz="1950" b="1">
                 <a:solidFill>
                   <a:srgbClr val="FFFFFF"/>
@@ -12727,6 +14049,7 @@
               </a:defRPr>
             </a:lvl6pPr>
             <a:lvl7pPr>
+              <a:buNone/>
               <a:defRPr sz="1950" b="1">
                 <a:solidFill>
                   <a:srgbClr val="FFFFFF"/>
@@ -12737,6 +14060,7 @@
               </a:defRPr>
             </a:lvl7pPr>
             <a:lvl8pPr>
+              <a:buNone/>
               <a:defRPr sz="1950" b="1">
                 <a:solidFill>
                   <a:srgbClr val="FFFFFF"/>
@@ -12747,6 +14071,7 @@
               </a:defRPr>
             </a:lvl8pPr>
             <a:lvl9pPr>
+              <a:buNone/>
               <a:defRPr sz="1950" b="1">
                 <a:solidFill>
                   <a:srgbClr val="FFFFFF"/>
@@ -12759,6 +14084,7 @@
           </a:lstStyle>
           <a:p xmlns:a="http://schemas.openxmlformats.org/drawingml/2006/main">
             <a:pPr>
+              <a:buNone/>
               <a:defRPr sz="1950" b="1">
                 <a:solidFill>
                   <a:srgbClr val="FFFFFF"/>
@@ -12823,6 +14149,7 @@
               </a:defRPr>
             </a:defPPr>
             <a:lvl1pPr>
+              <a:buNone/>
               <a:defRPr sz="1725" b="0">
                 <a:solidFill>
                   <a:srgbClr val="B9D0DE"/>
@@ -12833,6 +14160,7 @@
               </a:defRPr>
             </a:lvl1pPr>
             <a:lvl2pPr>
+              <a:buNone/>
               <a:defRPr sz="1725" b="0">
                 <a:solidFill>
                   <a:srgbClr val="B9D0DE"/>
@@ -12843,6 +14171,7 @@
               </a:defRPr>
             </a:lvl2pPr>
             <a:lvl3pPr>
+              <a:buNone/>
               <a:defRPr sz="1725" b="0">
                 <a:solidFill>
                   <a:srgbClr val="B9D0DE"/>
@@ -12853,6 +14182,7 @@
               </a:defRPr>
             </a:lvl3pPr>
             <a:lvl4pPr>
+              <a:buNone/>
               <a:defRPr sz="1725" b="0">
                 <a:solidFill>
                   <a:srgbClr val="B9D0DE"/>
@@ -12863,6 +14193,7 @@
               </a:defRPr>
             </a:lvl4pPr>
             <a:lvl5pPr>
+              <a:buNone/>
               <a:defRPr sz="1725" b="0">
                 <a:solidFill>
                   <a:srgbClr val="B9D0DE"/>
@@ -12873,6 +14204,7 @@
               </a:defRPr>
             </a:lvl5pPr>
             <a:lvl6pPr>
+              <a:buNone/>
               <a:defRPr sz="1725" b="0">
                 <a:solidFill>
                   <a:srgbClr val="B9D0DE"/>
@@ -12883,6 +14215,7 @@
               </a:defRPr>
             </a:lvl6pPr>
             <a:lvl7pPr>
+              <a:buNone/>
               <a:defRPr sz="1725" b="0">
                 <a:solidFill>
                   <a:srgbClr val="B9D0DE"/>
@@ -12893,6 +14226,7 @@
               </a:defRPr>
             </a:lvl7pPr>
             <a:lvl8pPr>
+              <a:buNone/>
               <a:defRPr sz="1725" b="0">
                 <a:solidFill>
                   <a:srgbClr val="B9D0DE"/>
@@ -12903,6 +14237,7 @@
               </a:defRPr>
             </a:lvl8pPr>
             <a:lvl9pPr>
+              <a:buNone/>
               <a:defRPr sz="1725" b="0">
                 <a:solidFill>
                   <a:srgbClr val="B9D0DE"/>
@@ -12915,6 +14250,7 @@
           </a:lstStyle>
           <a:p xmlns:a="http://schemas.openxmlformats.org/drawingml/2006/main">
             <a:pPr>
+              <a:buNone/>
               <a:defRPr sz="1725" b="0">
                 <a:solidFill>
                   <a:srgbClr val="B9D0DE"/>
@@ -12933,7 +14269,7 @@
                 <a:ea typeface="Helvetica Neue"/>
                 <a:cs typeface="Helvetica Neue"/>
               </a:rPr>
-              <a:t>Stop on request, topic coverage or turn limit; preserve unknowns. Failure preserves the typed answer.</a:t>
+              <a:t>Stop on request, coverage or turn cap; preserve unknowns. Failure retains the pending answer and committed state.</a:t>
             </a:r>
           </a:p>
         </p:txBody>
@@ -12979,6 +14315,7 @@
               </a:defRPr>
             </a:defPPr>
             <a:lvl1pPr>
+              <a:buNone/>
               <a:defRPr sz="1875" b="1">
                 <a:solidFill>
                   <a:srgbClr val="00A9D6"/>
@@ -12989,6 +14326,7 @@
               </a:defRPr>
             </a:lvl1pPr>
             <a:lvl2pPr>
+              <a:buNone/>
               <a:defRPr sz="1875" b="1">
                 <a:solidFill>
                   <a:srgbClr val="00A9D6"/>
@@ -12999,6 +14337,7 @@
               </a:defRPr>
             </a:lvl2pPr>
             <a:lvl3pPr>
+              <a:buNone/>
               <a:defRPr sz="1875" b="1">
                 <a:solidFill>
                   <a:srgbClr val="00A9D6"/>
@@ -13009,6 +14348,7 @@
               </a:defRPr>
             </a:lvl3pPr>
             <a:lvl4pPr>
+              <a:buNone/>
               <a:defRPr sz="1875" b="1">
                 <a:solidFill>
                   <a:srgbClr val="00A9D6"/>
@@ -13019,6 +14359,7 @@
               </a:defRPr>
             </a:lvl4pPr>
             <a:lvl5pPr>
+              <a:buNone/>
               <a:defRPr sz="1875" b="1">
                 <a:solidFill>
                   <a:srgbClr val="00A9D6"/>
@@ -13029,6 +14370,7 @@
               </a:defRPr>
             </a:lvl5pPr>
             <a:lvl6pPr>
+              <a:buNone/>
               <a:defRPr sz="1875" b="1">
                 <a:solidFill>
                   <a:srgbClr val="00A9D6"/>
@@ -13039,6 +14381,7 @@
               </a:defRPr>
             </a:lvl6pPr>
             <a:lvl7pPr>
+              <a:buNone/>
               <a:defRPr sz="1875" b="1">
                 <a:solidFill>
                   <a:srgbClr val="00A9D6"/>
@@ -13049,6 +14392,7 @@
               </a:defRPr>
             </a:lvl7pPr>
             <a:lvl8pPr>
+              <a:buNone/>
               <a:defRPr sz="1875" b="1">
                 <a:solidFill>
                   <a:srgbClr val="00A9D6"/>
@@ -13059,6 +14403,7 @@
               </a:defRPr>
             </a:lvl8pPr>
             <a:lvl9pPr>
+              <a:buNone/>
               <a:defRPr sz="1875" b="1">
                 <a:solidFill>
                   <a:srgbClr val="00A9D6"/>
@@ -13071,6 +14416,7 @@
           </a:lstStyle>
           <a:p xmlns:a="http://schemas.openxmlformats.org/drawingml/2006/main">
             <a:pPr>
+              <a:buNone/>
               <a:defRPr sz="1875" b="1">
                 <a:solidFill>
                   <a:srgbClr val="00A9D6"/>
@@ -13089,7 +14435,7 @@
                 <a:ea typeface="Helvetica Neue"/>
                 <a:cs typeface="Helvetica Neue"/>
               </a:rPr>
-              <a:t>56 passing tests + 7 guided probes; visible calls, tools, tokens, timings and source links</a:t>
+              <a:t>61 passing tests + 7 guided probes; inspect calls, tools, tokens, timings and source links</a:t>
             </a:r>
           </a:p>
         </p:txBody>
@@ -13135,6 +14481,7 @@
               </a:defRPr>
             </a:defPPr>
             <a:lvl1pPr>
+              <a:buNone/>
               <a:defRPr sz="1425" b="0">
                 <a:solidFill>
                   <a:srgbClr val="B9D0DE"/>
@@ -13145,6 +14492,7 @@
               </a:defRPr>
             </a:lvl1pPr>
             <a:lvl2pPr>
+              <a:buNone/>
               <a:defRPr sz="1425" b="0">
                 <a:solidFill>
                   <a:srgbClr val="B9D0DE"/>
@@ -13155,6 +14503,7 @@
               </a:defRPr>
             </a:lvl2pPr>
             <a:lvl3pPr>
+              <a:buNone/>
               <a:defRPr sz="1425" b="0">
                 <a:solidFill>
                   <a:srgbClr val="B9D0DE"/>
@@ -13165,6 +14514,7 @@
               </a:defRPr>
             </a:lvl3pPr>
             <a:lvl4pPr>
+              <a:buNone/>
               <a:defRPr sz="1425" b="0">
                 <a:solidFill>
                   <a:srgbClr val="B9D0DE"/>
@@ -13175,6 +14525,7 @@
               </a:defRPr>
             </a:lvl4pPr>
             <a:lvl5pPr>
+              <a:buNone/>
               <a:defRPr sz="1425" b="0">
                 <a:solidFill>
                   <a:srgbClr val="B9D0DE"/>
@@ -13185,6 +14536,7 @@
               </a:defRPr>
             </a:lvl5pPr>
             <a:lvl6pPr>
+              <a:buNone/>
               <a:defRPr sz="1425" b="0">
                 <a:solidFill>
                   <a:srgbClr val="B9D0DE"/>
@@ -13195,6 +14547,7 @@
               </a:defRPr>
             </a:lvl6pPr>
             <a:lvl7pPr>
+              <a:buNone/>
               <a:defRPr sz="1425" b="0">
                 <a:solidFill>
                   <a:srgbClr val="B9D0DE"/>
@@ -13205,6 +14558,7 @@
               </a:defRPr>
             </a:lvl7pPr>
             <a:lvl8pPr>
+              <a:buNone/>
               <a:defRPr sz="1425" b="0">
                 <a:solidFill>
                   <a:srgbClr val="B9D0DE"/>
@@ -13215,6 +14569,7 @@
               </a:defRPr>
             </a:lvl8pPr>
             <a:lvl9pPr>
+              <a:buNone/>
               <a:defRPr sz="1425" b="0">
                 <a:solidFill>
                   <a:srgbClr val="B9D0DE"/>
@@ -13227,6 +14582,7 @@
           </a:lstStyle>
           <a:p xmlns:a="http://schemas.openxmlformats.org/drawingml/2006/main">
             <a:pPr>
+              <a:buNone/>
               <a:defRPr sz="1425" b="0">
                 <a:solidFill>
                   <a:srgbClr val="B9D0DE"/>
@@ -13245,7 +14601,7 @@
                 <a:ea typeface="Helvetica Neue"/>
                 <a:cs typeface="Helvetica Neue"/>
               </a:rPr>
-              <a:t>Regression checks and synthetic voice smoke tests; no live-model accuracy or noisy-shop benchmark</a:t>
+              <a:t>Regression checks and voice smoke tests; live-model accuracy and noisy-shop reliability remain unmeasured</a:t>
             </a:r>
           </a:p>
         </p:txBody>
@@ -13291,6 +14647,7 @@
               </a:defRPr>
             </a:defPPr>
             <a:lvl1pPr>
+              <a:buNone/>
               <a:defRPr sz="1125" b="0">
                 <a:solidFill>
                   <a:srgbClr val="B9D0DE"/>
@@ -13301,6 +14658,7 @@
               </a:defRPr>
             </a:lvl1pPr>
             <a:lvl2pPr>
+              <a:buNone/>
               <a:defRPr sz="1125" b="0">
                 <a:solidFill>
                   <a:srgbClr val="B9D0DE"/>
@@ -13311,6 +14669,7 @@
               </a:defRPr>
             </a:lvl2pPr>
             <a:lvl3pPr>
+              <a:buNone/>
               <a:defRPr sz="1125" b="0">
                 <a:solidFill>
                   <a:srgbClr val="B9D0DE"/>
@@ -13321,6 +14680,7 @@
               </a:defRPr>
             </a:lvl3pPr>
             <a:lvl4pPr>
+              <a:buNone/>
               <a:defRPr sz="1125" b="0">
                 <a:solidFill>
                   <a:srgbClr val="B9D0DE"/>
@@ -13331,6 +14691,7 @@
               </a:defRPr>
             </a:lvl4pPr>
             <a:lvl5pPr>
+              <a:buNone/>
               <a:defRPr sz="1125" b="0">
                 <a:solidFill>
                   <a:srgbClr val="B9D0DE"/>
@@ -13341,6 +14702,7 @@
               </a:defRPr>
             </a:lvl5pPr>
             <a:lvl6pPr>
+              <a:buNone/>
               <a:defRPr sz="1125" b="0">
                 <a:solidFill>
                   <a:srgbClr val="B9D0DE"/>
@@ -13351,6 +14713,7 @@
               </a:defRPr>
             </a:lvl6pPr>
             <a:lvl7pPr>
+              <a:buNone/>
               <a:defRPr sz="1125" b="0">
                 <a:solidFill>
                   <a:srgbClr val="B9D0DE"/>
@@ -13361,6 +14724,7 @@
               </a:defRPr>
             </a:lvl7pPr>
             <a:lvl8pPr>
+              <a:buNone/>
               <a:defRPr sz="1125" b="0">
                 <a:solidFill>
                   <a:srgbClr val="B9D0DE"/>
@@ -13371,6 +14735,7 @@
               </a:defRPr>
             </a:lvl8pPr>
             <a:lvl9pPr>
+              <a:buNone/>
               <a:defRPr sz="1125" b="0">
                 <a:solidFill>
                   <a:srgbClr val="B9D0DE"/>
@@ -13383,6 +14748,7 @@
           </a:lstStyle>
           <a:p xmlns:a="http://schemas.openxmlformats.org/drawingml/2006/main">
             <a:pPr>
+              <a:buNone/>
               <a:defRPr sz="1125" b="0">
                 <a:solidFill>
                   <a:srgbClr val="B9D0DE"/>
@@ -13401,7 +14767,7 @@
                 <a:ea typeface="Helvetica Neue"/>
                 <a:cs typeface="Helvetica Neue"/>
               </a:rPr>
-              <a:t>MerchantLens · One harness, three Gemini roles; guided rules mode also available</a:t>
+              <a:t>One orchestrator · JSON between roles · same Gemini backend · no A2A protocol</a:t>
             </a:r>
           </a:p>
         </p:txBody>
@@ -13447,6 +14813,7 @@
               </a:defRPr>
             </a:defPPr>
             <a:lvl1pPr>
+              <a:buNone/>
               <a:defRPr sz="1125" b="0">
                 <a:solidFill>
                   <a:srgbClr val="B9D0DE"/>
@@ -13457,6 +14824,7 @@
               </a:defRPr>
             </a:lvl1pPr>
             <a:lvl2pPr>
+              <a:buNone/>
               <a:defRPr sz="1125" b="0">
                 <a:solidFill>
                   <a:srgbClr val="B9D0DE"/>
@@ -13467,6 +14835,7 @@
               </a:defRPr>
             </a:lvl2pPr>
             <a:lvl3pPr>
+              <a:buNone/>
               <a:defRPr sz="1125" b="0">
                 <a:solidFill>
                   <a:srgbClr val="B9D0DE"/>
@@ -13477,6 +14846,7 @@
               </a:defRPr>
             </a:lvl3pPr>
             <a:lvl4pPr>
+              <a:buNone/>
               <a:defRPr sz="1125" b="0">
                 <a:solidFill>
                   <a:srgbClr val="B9D0DE"/>
@@ -13487,6 +14857,7 @@
               </a:defRPr>
             </a:lvl4pPr>
             <a:lvl5pPr>
+              <a:buNone/>
               <a:defRPr sz="1125" b="0">
                 <a:solidFill>
                   <a:srgbClr val="B9D0DE"/>
@@ -13497,6 +14868,7 @@
               </a:defRPr>
             </a:lvl5pPr>
             <a:lvl6pPr>
+              <a:buNone/>
               <a:defRPr sz="1125" b="0">
                 <a:solidFill>
                   <a:srgbClr val="B9D0DE"/>
@@ -13507,6 +14879,7 @@
               </a:defRPr>
             </a:lvl6pPr>
             <a:lvl7pPr>
+              <a:buNone/>
               <a:defRPr sz="1125" b="0">
                 <a:solidFill>
                   <a:srgbClr val="B9D0DE"/>
@@ -13517,6 +14890,7 @@
               </a:defRPr>
             </a:lvl7pPr>
             <a:lvl8pPr>
+              <a:buNone/>
               <a:defRPr sz="1125" b="0">
                 <a:solidFill>
                   <a:srgbClr val="B9D0DE"/>
@@ -13527,6 +14901,7 @@
               </a:defRPr>
             </a:lvl8pPr>
             <a:lvl9pPr>
+              <a:buNone/>
               <a:defRPr sz="1125" b="0">
                 <a:solidFill>
                   <a:srgbClr val="B9D0DE"/>
@@ -13539,6 +14914,7 @@
           </a:lstStyle>
           <a:p xmlns:a="http://schemas.openxmlformats.org/drawingml/2006/main">
             <a:pPr>
+              <a:buNone/>
               <a:defRPr sz="1125" b="0">
                 <a:solidFill>
                   <a:srgbClr val="B9D0DE"/>
@@ -13752,7 +15128,7 @@
                 <a:ea typeface="Helvetica Neue"/>
                 <a:cs typeface="Helvetica Neue"/>
               </a:rPr>
-              <a:t>Paytm ROI, pilot and integration path</a:t>
+              <a:t>Five-layer continuity and Paytm pilot</a:t>
             </a:r>
           </a:p>
         </p:txBody>
@@ -13918,7 +15294,7 @@
                 <a:ea typeface="Helvetica Neue"/>
                 <a:cs typeface="Helvetica Neue"/>
               </a:rPr>
-              <a:t>Business hypothesis and measurement</a:t>
+              <a:t>What the extension does</a:t>
             </a:r>
           </a:p>
         </p:txBody>
@@ -14084,7 +15460,7 @@
                 <a:ea typeface="Helvetica Neue"/>
                 <a:cs typeface="Helvetica Neue"/>
               </a:rPr>
-              <a:t>Reduce repeat clarification and triage time</a:t>
+              <a:t>Preserve prior attempts and open questions</a:t>
             </a:r>
           </a:p>
         </p:txBody>
@@ -14250,7 +15626,7 @@
                 <a:ea typeface="Helvetica Neue"/>
                 <a:cs typeface="Helvetica Neue"/>
               </a:rPr>
-              <a:t>Pilot with 10 consenting merchants and operations reviewers. Compare the current intake flow with a reviewed MerchantLens brief.</a:t>
+              <a:t>Illustrative stages: clarify → review records → capture checks → prior contact → human handoff.</a:t>
             </a:r>
           </a:p>
         </p:txBody>
@@ -14416,7 +15792,7 @@
                 <a:ea typeface="Helvetica Neue"/>
                 <a:cs typeface="Helvetica Neue"/>
               </a:rPr>
-              <a:t>Measure time to a useful brief, repeat contacts, routing agreement, factual corrections, voice failures and AI cost per case.</a:t>
+              <a:t>Record source-linked history. Two unresolved entries recommend human review; a direct human request can skip all stages.</a:t>
             </a:r>
           </a:p>
         </p:txBody>
@@ -14581,7 +15957,7 @@
                 <a:latin typeface="Helvetica Neue"/>
                 <a:ea typeface="Helvetica Neue"/>
                 <a:cs typeface="Helvetica Neue"/>
-                <a:hlinkClick xmlns:r="http://schemas.openxmlformats.org/officeDocument/2006/relationships" r:id="Re67f8fc4739e4e0d"/>
+                <a:hlinkClick xmlns:r="http://schemas.openxmlformats.org/officeDocument/2006/relationships" r:id="Rf1e52d33198e43bc"/>
               </a:rPr>
               <a:t/>
             </a:r>
@@ -14748,7 +16124,7 @@
                 <a:latin typeface="Helvetica Neue"/>
                 <a:ea typeface="Helvetica Neue"/>
                 <a:cs typeface="Helvetica Neue"/>
-                <a:hlinkClick xmlns:r="http://schemas.openxmlformats.org/officeDocument/2006/relationships" r:id="R0bdfae6617a842f7"/>
+                <a:hlinkClick xmlns:r="http://schemas.openxmlformats.org/officeDocument/2006/relationships" r:id="Rb9c24d9f00de465c"/>
               </a:rPr>
               <a:t/>
             </a:r>
@@ -14772,7 +16148,7 @@
         <p:spPr>
           <a:xfrm xmlns:a="http://schemas.openxmlformats.org/drawingml/2006/main">
             <a:off x="704850" y="5048250"/>
-            <a:ext cx="5162550" cy="781050"/>
+            <a:ext cx="5162550" cy="876300"/>
           </a:xfrm>
           <a:prstGeom xmlns:a="http://schemas.openxmlformats.org/drawingml/2006/main" prst="rect">
             <a:avLst/>
@@ -14786,7 +16162,7 @@
           <a:bodyPr xmlns:a="http://schemas.openxmlformats.org/drawingml/2006/main" lIns="0" tIns="0" rIns="0" bIns="0" anchor="t"/>
           <a:lstStyle xmlns:a="http://schemas.openxmlformats.org/drawingml/2006/main">
             <a:defPPr>
-              <a:defRPr sz="1875" b="1">
+              <a:defRPr sz="1725" b="1">
                 <a:solidFill>
                   <a:srgbClr val="102F43"/>
                 </a:solidFill>
@@ -14908,7 +16284,7 @@
               </a:defRPr>
             </a:pPr>
             <a:r>
-              <a:rPr sz="1875" b="1">
+              <a:rPr sz="1725" b="1">
                 <a:solidFill>
                   <a:srgbClr val="102F43"/>
                 </a:solidFill>
@@ -14916,31 +16292,7 @@
                 <a:ea typeface="Helvetica Neue"/>
                 <a:cs typeface="Helvetica Neue"/>
               </a:rPr>
-              <a:t>Net value = cases × minutes saved × staff cost/min</a:t>
-            </a:r>
-          </a:p>
-          <a:p xmlns:a="http://schemas.openxmlformats.org/drawingml/2006/main">
-            <a:pPr>
-              <a:buNone/>
-              <a:defRPr sz="1875" b="1">
-                <a:solidFill>
-                  <a:srgbClr val="102F43"/>
-                </a:solidFill>
-                <a:latin typeface="Helvetica Neue"/>
-                <a:ea typeface="Helvetica Neue"/>
-                <a:cs typeface="Helvetica Neue"/>
-              </a:defRPr>
-            </a:pPr>
-            <a:r>
-              <a:rPr sz="1875" b="1">
-                <a:solidFill>
-                  <a:srgbClr val="102F43"/>
-                </a:solidFill>
-                <a:latin typeface="Helvetica Neue"/>
-                <a:ea typeface="Helvetica Neue"/>
-                <a:cs typeface="Helvetica Neue"/>
-              </a:rPr>
-              <a:t>− AI, review, integration and operating costs</a:t>
+              <a:t>Net value = cases × minutes saved × staff cost/min − AI, review and operating costs.</a:t>
             </a:r>
           </a:p>
         </p:txBody>
@@ -15106,7 +16458,7 @@
                 <a:ea typeface="Helvetica Neue"/>
                 <a:cs typeface="Helvetica Neue"/>
               </a:rPr>
-              <a:t>Proposed Paytm integration</a:t>
+              <a:t>Pilot and production gap</a:t>
             </a:r>
           </a:p>
         </p:txBody>
@@ -15142,7 +16494,7 @@
           <a:bodyPr xmlns:a="http://schemas.openxmlformats.org/drawingml/2006/main" lIns="0" tIns="0" rIns="0" bIns="0" anchor="t"/>
           <a:lstStyle xmlns:a="http://schemas.openxmlformats.org/drawingml/2006/main">
             <a:defPPr>
-              <a:defRPr sz="1800" b="0">
+              <a:defRPr sz="1725" b="0">
                 <a:solidFill>
                   <a:srgbClr val="102F43"/>
                 </a:solidFill>
@@ -15264,7 +16616,7 @@
               </a:defRPr>
             </a:pPr>
             <a:r>
-              <a:rPr sz="1800" b="0">
+              <a:rPr sz="1725" b="0">
                 <a:solidFill>
                   <a:srgbClr val="102F43"/>
                 </a:solidFill>
@@ -15272,7 +16624,7 @@
                 <a:ea typeface="Helvetica Neue"/>
                 <a:cs typeface="Helvetica Neue"/>
               </a:rPr>
-              <a:t>1  Consent + authenticated merchant identity</a:t>
+              <a:t>Pilot: 10 consenting merchants; compare baseline</a:t>
             </a:r>
           </a:p>
           <a:p xmlns:a="http://schemas.openxmlformats.org/drawingml/2006/main">
@@ -15288,7 +16640,7 @@
               </a:defRPr>
             </a:pPr>
             <a:r>
-              <a:rPr sz="1800" b="0">
+              <a:rPr sz="1725" b="0">
                 <a:solidFill>
                   <a:srgbClr val="102F43"/>
                 </a:solidFill>
@@ -15296,7 +16648,7 @@
                 <a:ea typeface="Helvetica Neue"/>
                 <a:cs typeface="Helvetica Neue"/>
               </a:rPr>
-              <a:t>2  Read-only transaction/settlement/device context</a:t>
+              <a:t>Measure minutes, recontacts and reviewer usefulness</a:t>
             </a:r>
           </a:p>
           <a:p xmlns:a="http://schemas.openxmlformats.org/drawingml/2006/main">
@@ -15312,7 +16664,7 @@
               </a:defRPr>
             </a:pPr>
             <a:r>
-              <a:rPr sz="1800" b="0">
+              <a:rPr sz="1725" b="0">
                 <a:solidFill>
                   <a:srgbClr val="102F43"/>
                 </a:solidFill>
@@ -15320,7 +16672,7 @@
                 <a:ea typeface="Helvetica Neue"/>
                 <a:cs typeface="Helvetica Neue"/>
               </a:rPr>
-              <a:t>3  Reconcile merchant reports with system records</a:t>
+              <a:t>Track corrections, voice failures and cost per case</a:t>
             </a:r>
           </a:p>
           <a:p xmlns:a="http://schemas.openxmlformats.org/drawingml/2006/main">
@@ -15336,7 +16688,7 @@
               </a:defRPr>
             </a:pPr>
             <a:r>
-              <a:rPr sz="1800" b="0">
+              <a:rPr sz="1725" b="0">
                 <a:solidFill>
                   <a:srgbClr val="102F43"/>
                 </a:solidFill>
@@ -15344,7 +16696,7 @@
                 <a:ea typeface="Helvetica Neue"/>
                 <a:cs typeface="Helvetica Neue"/>
               </a:rPr>
-              <a:t>4  Human-reviewed case in the support workflow</a:t>
+              <a:t>Next: authorized history/payment/device adapters</a:t>
             </a:r>
           </a:p>
           <a:p xmlns:a="http://schemas.openxmlformats.org/drawingml/2006/main">
@@ -15360,7 +16712,7 @@
               </a:defRPr>
             </a:pPr>
             <a:r>
-              <a:rPr sz="1800" b="0">
+              <a:rPr sz="1725" b="0">
                 <a:solidFill>
                   <a:srgbClr val="102F43"/>
                 </a:solidFill>
@@ -15368,7 +16720,7 @@
                 <a:ea typeface="Helvetica Neue"/>
                 <a:cs typeface="Helvetica Neue"/>
               </a:rPr>
-              <a:t>5  Product insights from anonymized briefs</a:t>
+              <a:t>Then: reviewed, idempotent ticket submission</a:t>
             </a:r>
           </a:p>
         </p:txBody>
@@ -15700,7 +17052,7 @@
                 <a:ea typeface="Helvetica Neue"/>
                 <a:cs typeface="Helvetica Neue"/>
               </a:rPr>
-              <a:t>Source-valid claims and current-version approval; zero unauthorized actions; security/privacy review; measured intake benefit within an agreed cost and latency budget.</a:t>
+              <a:t>Require source-valid claims, fresh approval, no unauthorized actions and agreed quality/cost/latency targets. Paytm’s true layers and APIs still need confirmation.</a:t>
             </a:r>
           </a:p>
         </p:txBody>
@@ -15746,6 +17098,7 @@
               </a:defRPr>
             </a:defPPr>
             <a:lvl1pPr>
+              <a:buNone/>
               <a:defRPr sz="1500" b="0">
                 <a:solidFill>
                   <a:srgbClr val="526B7C"/>
@@ -15756,6 +17109,7 @@
               </a:defRPr>
             </a:lvl1pPr>
             <a:lvl2pPr>
+              <a:buNone/>
               <a:defRPr sz="1500" b="0">
                 <a:solidFill>
                   <a:srgbClr val="526B7C"/>
@@ -15766,6 +17120,7 @@
               </a:defRPr>
             </a:lvl2pPr>
             <a:lvl3pPr>
+              <a:buNone/>
               <a:defRPr sz="1500" b="0">
                 <a:solidFill>
                   <a:srgbClr val="526B7C"/>
@@ -15776,6 +17131,7 @@
               </a:defRPr>
             </a:lvl3pPr>
             <a:lvl4pPr>
+              <a:buNone/>
               <a:defRPr sz="1500" b="0">
                 <a:solidFill>
                   <a:srgbClr val="526B7C"/>
@@ -15786,6 +17142,7 @@
               </a:defRPr>
             </a:lvl4pPr>
             <a:lvl5pPr>
+              <a:buNone/>
               <a:defRPr sz="1500" b="0">
                 <a:solidFill>
                   <a:srgbClr val="526B7C"/>
@@ -15796,6 +17153,7 @@
               </a:defRPr>
             </a:lvl5pPr>
             <a:lvl6pPr>
+              <a:buNone/>
               <a:defRPr sz="1500" b="0">
                 <a:solidFill>
                   <a:srgbClr val="526B7C"/>
@@ -15806,6 +17164,7 @@
               </a:defRPr>
             </a:lvl6pPr>
             <a:lvl7pPr>
+              <a:buNone/>
               <a:defRPr sz="1500" b="0">
                 <a:solidFill>
                   <a:srgbClr val="526B7C"/>
@@ -15816,6 +17175,7 @@
               </a:defRPr>
             </a:lvl7pPr>
             <a:lvl8pPr>
+              <a:buNone/>
               <a:defRPr sz="1500" b="0">
                 <a:solidFill>
                   <a:srgbClr val="526B7C"/>
@@ -15826,6 +17186,7 @@
               </a:defRPr>
             </a:lvl8pPr>
             <a:lvl9pPr>
+              <a:buNone/>
               <a:defRPr sz="1500" b="0">
                 <a:solidFill>
                   <a:srgbClr val="526B7C"/>
@@ -15838,6 +17199,7 @@
           </a:lstStyle>
           <a:p xmlns:a="http://schemas.openxmlformats.org/drawingml/2006/main">
             <a:pPr>
+              <a:buNone/>
               <a:defRPr sz="1500" b="0">
                 <a:solidFill>
                   <a:srgbClr val="526B7C"/>
@@ -15856,7 +17218,7 @@
                 <a:ea typeface="Helvetica Neue"/>
                 <a:cs typeface="Helvetica Neue"/>
               </a:rPr>
-              <a:t>Pilot proposal, not measured savings. Paytm APIs, telephony and shared production storage are not connected.</a:t>
+              <a:t>Manual history entry; no ticket sent. Savings and live-model accuracy remain unmeasured.</a:t>
             </a:r>
           </a:p>
         </p:txBody>
@@ -15902,6 +17264,7 @@
               </a:defRPr>
             </a:defPPr>
             <a:lvl1pPr>
+              <a:buNone/>
               <a:defRPr sz="1200" b="0">
                 <a:solidFill>
                   <a:srgbClr val="526B7C"/>
@@ -15912,6 +17275,7 @@
               </a:defRPr>
             </a:lvl1pPr>
             <a:lvl2pPr>
+              <a:buNone/>
               <a:defRPr sz="1200" b="0">
                 <a:solidFill>
                   <a:srgbClr val="526B7C"/>
@@ -15922,6 +17286,7 @@
               </a:defRPr>
             </a:lvl2pPr>
             <a:lvl3pPr>
+              <a:buNone/>
               <a:defRPr sz="1200" b="0">
                 <a:solidFill>
                   <a:srgbClr val="526B7C"/>
@@ -15932,6 +17297,7 @@
               </a:defRPr>
             </a:lvl3pPr>
             <a:lvl4pPr>
+              <a:buNone/>
               <a:defRPr sz="1200" b="0">
                 <a:solidFill>
                   <a:srgbClr val="526B7C"/>
@@ -15942,6 +17308,7 @@
               </a:defRPr>
             </a:lvl4pPr>
             <a:lvl5pPr>
+              <a:buNone/>
               <a:defRPr sz="1200" b="0">
                 <a:solidFill>
                   <a:srgbClr val="526B7C"/>
@@ -15952,6 +17319,7 @@
               </a:defRPr>
             </a:lvl5pPr>
             <a:lvl6pPr>
+              <a:buNone/>
               <a:defRPr sz="1200" b="0">
                 <a:solidFill>
                   <a:srgbClr val="526B7C"/>
@@ -15962,6 +17330,7 @@
               </a:defRPr>
             </a:lvl6pPr>
             <a:lvl7pPr>
+              <a:buNone/>
               <a:defRPr sz="1200" b="0">
                 <a:solidFill>
                   <a:srgbClr val="526B7C"/>
@@ -15972,6 +17341,7 @@
               </a:defRPr>
             </a:lvl7pPr>
             <a:lvl8pPr>
+              <a:buNone/>
               <a:defRPr sz="1200" b="0">
                 <a:solidFill>
                   <a:srgbClr val="526B7C"/>
@@ -15982,6 +17352,7 @@
               </a:defRPr>
             </a:lvl8pPr>
             <a:lvl9pPr>
+              <a:buNone/>
               <a:defRPr sz="1200" b="0">
                 <a:solidFill>
                   <a:srgbClr val="526B7C"/>
@@ -15994,6 +17365,7 @@
           </a:lstStyle>
           <a:p xmlns:a="http://schemas.openxmlformats.org/drawingml/2006/main">
             <a:pPr>
+              <a:buNone/>
               <a:defRPr sz="1200" b="0">
                 <a:solidFill>
                   <a:srgbClr val="526B7C"/>
@@ -16056,7 +17428,7 @@
                 <a:latin typeface="Helvetica Neue"/>
                 <a:ea typeface="Helvetica Neue"/>
                 <a:cs typeface="Helvetica Neue"/>
-                <a:hlinkClick xmlns:r="http://schemas.openxmlformats.org/officeDocument/2006/relationships" r:id="R73b4aabcee164d20"/>
+                <a:hlinkClick xmlns:r="http://schemas.openxmlformats.org/officeDocument/2006/relationships" r:id="Rb5ca311d0f354dd8"/>
               </a:rPr>
               <a:t>Live app</a:t>
             </a:r>
@@ -16102,7 +17474,7 @@
                 <a:latin typeface="Helvetica Neue"/>
                 <a:ea typeface="Helvetica Neue"/>
                 <a:cs typeface="Helvetica Neue"/>
-                <a:hlinkClick xmlns:r="http://schemas.openxmlformats.org/officeDocument/2006/relationships" r:id="R221b12dbe32d45f5"/>
+                <a:hlinkClick xmlns:r="http://schemas.openxmlformats.org/officeDocument/2006/relationships" r:id="R425201b393f943a1"/>
               </a:rPr>
               <a:t>GitHub + architecture</a:t>
             </a:r>
@@ -16148,7 +17520,7 @@
                 <a:latin typeface="Helvetica Neue"/>
                 <a:ea typeface="Helvetica Neue"/>
                 <a:cs typeface="Helvetica Neue"/>
-                <a:hlinkClick xmlns:r="http://schemas.openxmlformats.org/officeDocument/2006/relationships" r:id="Rc6e8a516bcad40bd"/>
+                <a:hlinkClick xmlns:r="http://schemas.openxmlformats.org/officeDocument/2006/relationships" r:id="R8dec0791f1e14393"/>
               </a:rPr>
               <a:t>Backup video</a:t>
             </a:r>

</xml_diff>